<commit_message>
One more new pres
</commit_message>
<xml_diff>
--- a/docs/PDD.pptx
+++ b/docs/PDD.pptx
@@ -6,16 +6,13 @@
   </p:sldMasterIdLst>
   <p:sldIdLst>
     <p:sldId id="256" r:id="rId2"/>
-    <p:sldId id="267" r:id="rId3"/>
-    <p:sldId id="268" r:id="rId4"/>
-    <p:sldId id="270" r:id="rId5"/>
-    <p:sldId id="257" r:id="rId6"/>
-    <p:sldId id="258" r:id="rId7"/>
-    <p:sldId id="266" r:id="rId8"/>
-    <p:sldId id="263" r:id="rId9"/>
-    <p:sldId id="262" r:id="rId10"/>
-    <p:sldId id="264" r:id="rId11"/>
-    <p:sldId id="265" r:id="rId12"/>
+    <p:sldId id="270" r:id="rId3"/>
+    <p:sldId id="257" r:id="rId4"/>
+    <p:sldId id="258" r:id="rId5"/>
+    <p:sldId id="268" r:id="rId6"/>
+    <p:sldId id="262" r:id="rId7"/>
+    <p:sldId id="264" r:id="rId8"/>
+    <p:sldId id="265" r:id="rId9"/>
   </p:sldIdLst>
   <p:sldSz cx="12192000" cy="6858000"/>
   <p:notesSz cx="6858000" cy="9144000"/>
@@ -269,7 +266,7 @@
           <a:p>
             <a:fld id="{B0162680-E6D0-4128-AB2B-3DCCBE8A049F}" type="datetimeFigureOut">
               <a:rPr lang="ru-RU" smtClean="0"/>
-              <a:t>03.03.2026</a:t>
+              <a:t>20.05.2026</a:t>
             </a:fld>
             <a:endParaRPr lang="ru-RU"/>
           </a:p>
@@ -467,7 +464,7 @@
           <a:p>
             <a:fld id="{B0162680-E6D0-4128-AB2B-3DCCBE8A049F}" type="datetimeFigureOut">
               <a:rPr lang="ru-RU" smtClean="0"/>
-              <a:t>03.03.2026</a:t>
+              <a:t>20.05.2026</a:t>
             </a:fld>
             <a:endParaRPr lang="ru-RU"/>
           </a:p>
@@ -675,7 +672,7 @@
           <a:p>
             <a:fld id="{B0162680-E6D0-4128-AB2B-3DCCBE8A049F}" type="datetimeFigureOut">
               <a:rPr lang="ru-RU" smtClean="0"/>
-              <a:t>03.03.2026</a:t>
+              <a:t>20.05.2026</a:t>
             </a:fld>
             <a:endParaRPr lang="ru-RU"/>
           </a:p>
@@ -873,7 +870,7 @@
           <a:p>
             <a:fld id="{B0162680-E6D0-4128-AB2B-3DCCBE8A049F}" type="datetimeFigureOut">
               <a:rPr lang="ru-RU" smtClean="0"/>
-              <a:t>03.03.2026</a:t>
+              <a:t>20.05.2026</a:t>
             </a:fld>
             <a:endParaRPr lang="ru-RU"/>
           </a:p>
@@ -1148,7 +1145,7 @@
           <a:p>
             <a:fld id="{B0162680-E6D0-4128-AB2B-3DCCBE8A049F}" type="datetimeFigureOut">
               <a:rPr lang="ru-RU" smtClean="0"/>
-              <a:t>03.03.2026</a:t>
+              <a:t>20.05.2026</a:t>
             </a:fld>
             <a:endParaRPr lang="ru-RU"/>
           </a:p>
@@ -1413,7 +1410,7 @@
           <a:p>
             <a:fld id="{B0162680-E6D0-4128-AB2B-3DCCBE8A049F}" type="datetimeFigureOut">
               <a:rPr lang="ru-RU" smtClean="0"/>
-              <a:t>03.03.2026</a:t>
+              <a:t>20.05.2026</a:t>
             </a:fld>
             <a:endParaRPr lang="ru-RU"/>
           </a:p>
@@ -1825,7 +1822,7 @@
           <a:p>
             <a:fld id="{B0162680-E6D0-4128-AB2B-3DCCBE8A049F}" type="datetimeFigureOut">
               <a:rPr lang="ru-RU" smtClean="0"/>
-              <a:t>03.03.2026</a:t>
+              <a:t>20.05.2026</a:t>
             </a:fld>
             <a:endParaRPr lang="ru-RU"/>
           </a:p>
@@ -1966,7 +1963,7 @@
           <a:p>
             <a:fld id="{B0162680-E6D0-4128-AB2B-3DCCBE8A049F}" type="datetimeFigureOut">
               <a:rPr lang="ru-RU" smtClean="0"/>
-              <a:t>03.03.2026</a:t>
+              <a:t>20.05.2026</a:t>
             </a:fld>
             <a:endParaRPr lang="ru-RU"/>
           </a:p>
@@ -2079,7 +2076,7 @@
           <a:p>
             <a:fld id="{B0162680-E6D0-4128-AB2B-3DCCBE8A049F}" type="datetimeFigureOut">
               <a:rPr lang="ru-RU" smtClean="0"/>
-              <a:t>03.03.2026</a:t>
+              <a:t>20.05.2026</a:t>
             </a:fld>
             <a:endParaRPr lang="ru-RU"/>
           </a:p>
@@ -2390,7 +2387,7 @@
           <a:p>
             <a:fld id="{B0162680-E6D0-4128-AB2B-3DCCBE8A049F}" type="datetimeFigureOut">
               <a:rPr lang="ru-RU" smtClean="0"/>
-              <a:t>03.03.2026</a:t>
+              <a:t>20.05.2026</a:t>
             </a:fld>
             <a:endParaRPr lang="ru-RU"/>
           </a:p>
@@ -2678,7 +2675,7 @@
           <a:p>
             <a:fld id="{B0162680-E6D0-4128-AB2B-3DCCBE8A049F}" type="datetimeFigureOut">
               <a:rPr lang="ru-RU" smtClean="0"/>
-              <a:t>03.03.2026</a:t>
+              <a:t>20.05.2026</a:t>
             </a:fld>
             <a:endParaRPr lang="ru-RU"/>
           </a:p>
@@ -2919,7 +2916,7 @@
           <a:p>
             <a:fld id="{B0162680-E6D0-4128-AB2B-3DCCBE8A049F}" type="datetimeFigureOut">
               <a:rPr lang="ru-RU" smtClean="0"/>
-              <a:t>03.03.2026</a:t>
+              <a:t>20.05.2026</a:t>
             </a:fld>
             <a:endParaRPr lang="ru-RU"/>
           </a:p>
@@ -3414,7 +3411,37 @@
                   </a:schemeClr>
                 </a:solidFill>
               </a:rPr>
-              <a:t>Команда проекта: Планов Богдан Григорьевич, Атаманов Данила Евгеньевич, Чернышов Иван Максимович</a:t>
+              <a:t>Команда проекта: Планов Богдан</a:t>
+            </a:r>
+            <a:r>
+              <a:rPr lang="en-US" sz="1600" dirty="0">
+                <a:solidFill>
+                  <a:schemeClr val="bg2">
+                    <a:lumMod val="50000"/>
+                  </a:schemeClr>
+                </a:solidFill>
+              </a:rPr>
+              <a:t>, </a:t>
+            </a:r>
+            <a:r>
+              <a:rPr lang="ru-RU" sz="1600" dirty="0" err="1">
+                <a:solidFill>
+                  <a:schemeClr val="bg2">
+                    <a:lumMod val="50000"/>
+                  </a:schemeClr>
+                </a:solidFill>
+              </a:rPr>
+              <a:t>Краснодубский</a:t>
+            </a:r>
+            <a:r>
+              <a:rPr lang="ru-RU" sz="1600" dirty="0">
+                <a:solidFill>
+                  <a:schemeClr val="bg2">
+                    <a:lumMod val="50000"/>
+                  </a:schemeClr>
+                </a:solidFill>
+              </a:rPr>
+              <a:t> Илья</a:t>
             </a:r>
           </a:p>
           <a:p>
@@ -3651,1015 +3678,7 @@
 </p:sld>
 </file>
 
-<file path=ppt/slides/slide10.xml><?xml version="1.0" encoding="utf-8"?>
-<p:sld xmlns:a="http://schemas.openxmlformats.org/drawingml/2006/main" xmlns:r="http://schemas.openxmlformats.org/officeDocument/2006/relationships" xmlns:p="http://schemas.openxmlformats.org/presentationml/2006/main">
-  <p:cSld>
-    <p:spTree>
-      <p:nvGrpSpPr>
-        <p:cNvPr id="1" name=""/>
-        <p:cNvGrpSpPr/>
-        <p:nvPr/>
-      </p:nvGrpSpPr>
-      <p:grpSpPr>
-        <a:xfrm>
-          <a:off x="0" y="0"/>
-          <a:ext cx="0" cy="0"/>
-          <a:chOff x="0" y="0"/>
-          <a:chExt cx="0" cy="0"/>
-        </a:xfrm>
-      </p:grpSpPr>
-      <p:sp>
-        <p:nvSpPr>
-          <p:cNvPr id="2" name="Заголовок 1">
-            <a:extLst>
-              <a:ext uri="{FF2B5EF4-FFF2-40B4-BE49-F238E27FC236}">
-                <a16:creationId xmlns:a16="http://schemas.microsoft.com/office/drawing/2014/main" id="{7D943821-AECF-4A55-8E12-49D7F394EDD7}"/>
-              </a:ext>
-            </a:extLst>
-          </p:cNvPr>
-          <p:cNvSpPr>
-            <a:spLocks noGrp="1"/>
-          </p:cNvSpPr>
-          <p:nvPr>
-            <p:ph type="title"/>
-          </p:nvPr>
-        </p:nvSpPr>
-        <p:spPr>
-          <a:xfrm>
-            <a:off x="3533358" y="238540"/>
-            <a:ext cx="5125279" cy="764999"/>
-          </a:xfrm>
-        </p:spPr>
-        <p:txBody>
-          <a:bodyPr>
-            <a:normAutofit/>
-          </a:bodyPr>
-          <a:lstStyle/>
-          <a:p>
-            <a:r>
-              <a:rPr lang="ru-RU" sz="4000" dirty="0"/>
-              <a:t>Дальнейшее  развитие</a:t>
-            </a:r>
-          </a:p>
-        </p:txBody>
-      </p:sp>
-      <p:pic>
-        <p:nvPicPr>
-          <p:cNvPr id="2050" name="Picture 2" descr="Развитие">
-            <a:extLst>
-              <a:ext uri="{FF2B5EF4-FFF2-40B4-BE49-F238E27FC236}">
-                <a16:creationId xmlns:a16="http://schemas.microsoft.com/office/drawing/2014/main" id="{FDC0DFEF-B865-A3A4-4B8C-50327729B1C4}"/>
-              </a:ext>
-            </a:extLst>
-          </p:cNvPr>
-          <p:cNvPicPr>
-            <a:picLocks noChangeAspect="1" noChangeArrowheads="1"/>
-          </p:cNvPicPr>
-          <p:nvPr/>
-        </p:nvPicPr>
-        <p:blipFill>
-          <a:blip r:embed="rId2">
-            <a:extLst>
-              <a:ext uri="{28A0092B-C50C-407E-A947-70E740481C1C}">
-                <a14:useLocalDpi xmlns:a14="http://schemas.microsoft.com/office/drawing/2010/main" val="0"/>
-              </a:ext>
-            </a:extLst>
-          </a:blip>
-          <a:srcRect/>
-          <a:stretch>
-            <a:fillRect/>
-          </a:stretch>
-        </p:blipFill>
-        <p:spPr bwMode="auto">
-          <a:xfrm>
-            <a:off x="9742004" y="4154557"/>
-            <a:ext cx="2449995" cy="2703443"/>
-          </a:xfrm>
-          <a:prstGeom prst="rect">
-            <a:avLst/>
-          </a:prstGeom>
-          <a:noFill/>
-          <a:extLst>
-            <a:ext uri="{909E8E84-426E-40DD-AFC4-6F175D3DCCD1}">
-              <a14:hiddenFill xmlns:a14="http://schemas.microsoft.com/office/drawing/2010/main">
-                <a:solidFill>
-                  <a:srgbClr val="FFFFFF"/>
-                </a:solidFill>
-              </a14:hiddenFill>
-            </a:ext>
-          </a:extLst>
-        </p:spPr>
-      </p:pic>
-      <p:sp>
-        <p:nvSpPr>
-          <p:cNvPr id="3" name="TextBox 2">
-            <a:extLst>
-              <a:ext uri="{FF2B5EF4-FFF2-40B4-BE49-F238E27FC236}">
-                <a16:creationId xmlns:a16="http://schemas.microsoft.com/office/drawing/2014/main" id="{717A9FA7-B1B1-62D8-C2C2-58149670A106}"/>
-              </a:ext>
-            </a:extLst>
-          </p:cNvPr>
-          <p:cNvSpPr txBox="1"/>
-          <p:nvPr/>
-        </p:nvSpPr>
-        <p:spPr>
-          <a:xfrm>
-            <a:off x="1592745" y="1859339"/>
-            <a:ext cx="9006507" cy="3139321"/>
-          </a:xfrm>
-          <a:prstGeom prst="rect">
-            <a:avLst/>
-          </a:prstGeom>
-          <a:noFill/>
-        </p:spPr>
-        <p:txBody>
-          <a:bodyPr wrap="square" rtlCol="0">
-            <a:spAutoFit/>
-          </a:bodyPr>
-          <a:lstStyle/>
-          <a:p>
-            <a:r>
-              <a:rPr lang="en-US" sz="2200" dirty="0"/>
-              <a:t>PDD</a:t>
-            </a:r>
-            <a:r>
-              <a:rPr lang="ru-RU" sz="2200" dirty="0"/>
-              <a:t> будет развиваться постепенно:</a:t>
-            </a:r>
-          </a:p>
-          <a:p>
-            <a:pPr marL="285750" indent="-285750">
-              <a:buFont typeface="Arial" panose="020B0604020202020204" pitchFamily="34" charset="0"/>
-              <a:buChar char="•"/>
-            </a:pPr>
-            <a:r>
-              <a:rPr lang="ru-RU" sz="2200" dirty="0"/>
-              <a:t>Будут добавляться новые команды: получение процента </a:t>
-            </a:r>
-            <a:r>
-              <a:rPr lang="en-US" sz="2200" dirty="0"/>
-              <a:t>S.M.A.R.T., </a:t>
-            </a:r>
-            <a:r>
-              <a:rPr lang="ru-RU" sz="2200" dirty="0"/>
-              <a:t>времени наработки, объём записанных данных и подобные</a:t>
-            </a:r>
-          </a:p>
-          <a:p>
-            <a:pPr marL="285750" indent="-285750">
-              <a:buFont typeface="Arial" panose="020B0604020202020204" pitchFamily="34" charset="0"/>
-              <a:buChar char="•"/>
-            </a:pPr>
-            <a:r>
-              <a:rPr lang="ru-RU" sz="2200" dirty="0"/>
-              <a:t>Будет порт для </a:t>
-            </a:r>
-            <a:r>
-              <a:rPr lang="en-US" sz="2200" dirty="0"/>
-              <a:t>MacOS, FreeBSD </a:t>
-            </a:r>
-            <a:r>
-              <a:rPr lang="ru-RU" sz="2200" dirty="0"/>
-              <a:t>и других </a:t>
-            </a:r>
-            <a:r>
-              <a:rPr lang="en-US" sz="2200" dirty="0"/>
-              <a:t>UNIX-</a:t>
-            </a:r>
-            <a:r>
-              <a:rPr lang="ru-RU" sz="2200" dirty="0" err="1"/>
-              <a:t>овых</a:t>
-            </a:r>
-            <a:r>
-              <a:rPr lang="ru-RU" sz="2200" dirty="0"/>
-              <a:t> ОС</a:t>
-            </a:r>
-          </a:p>
-          <a:p>
-            <a:pPr marL="285750" indent="-285750">
-              <a:buFont typeface="Arial" panose="020B0604020202020204" pitchFamily="34" charset="0"/>
-              <a:buChar char="•"/>
-            </a:pPr>
-            <a:r>
-              <a:rPr lang="ru-RU" sz="2200" dirty="0"/>
-              <a:t>Планируется добавление более низкоуровневых функций, а также поддержки других архитектур</a:t>
-            </a:r>
-          </a:p>
-          <a:p>
-            <a:pPr marL="285750" indent="-285750">
-              <a:buFont typeface="Arial" panose="020B0604020202020204" pitchFamily="34" charset="0"/>
-              <a:buChar char="•"/>
-            </a:pPr>
-            <a:r>
-              <a:rPr lang="ru-RU" sz="2200" dirty="0"/>
-              <a:t>Будут собираться отчеты об ошибках и исправляться баги</a:t>
-            </a:r>
-          </a:p>
-          <a:p>
-            <a:pPr marL="285750" indent="-285750">
-              <a:buFont typeface="Arial" panose="020B0604020202020204" pitchFamily="34" charset="0"/>
-              <a:buChar char="•"/>
-            </a:pPr>
-            <a:r>
-              <a:rPr lang="ru-RU" sz="2200" dirty="0"/>
-              <a:t>Планируется добавление этой программы в репозитории пакетных менеджеров (</a:t>
-            </a:r>
-            <a:r>
-              <a:rPr lang="en-US" sz="2200" dirty="0"/>
-              <a:t>apt, </a:t>
-            </a:r>
-            <a:r>
-              <a:rPr lang="en-US" sz="2200" dirty="0" err="1"/>
-              <a:t>pacman</a:t>
-            </a:r>
-            <a:r>
-              <a:rPr lang="en-US" sz="2200" dirty="0"/>
-              <a:t>, emerge, </a:t>
-            </a:r>
-            <a:r>
-              <a:rPr lang="en-US" sz="2200" dirty="0" err="1"/>
-              <a:t>dnf</a:t>
-            </a:r>
-            <a:r>
-              <a:rPr lang="en-US" sz="2200" dirty="0"/>
-              <a:t> </a:t>
-            </a:r>
-            <a:r>
-              <a:rPr lang="ru-RU" sz="2200" dirty="0"/>
-              <a:t>и других)</a:t>
-            </a:r>
-            <a:endParaRPr lang="en-US" sz="2200" dirty="0"/>
-          </a:p>
-        </p:txBody>
-      </p:sp>
-    </p:spTree>
-    <p:extLst>
-      <p:ext uri="{BB962C8B-B14F-4D97-AF65-F5344CB8AC3E}">
-        <p14:creationId xmlns:p14="http://schemas.microsoft.com/office/powerpoint/2010/main" val="1961248313"/>
-      </p:ext>
-    </p:extLst>
-  </p:cSld>
-  <p:clrMapOvr>
-    <a:masterClrMapping/>
-  </p:clrMapOvr>
-  <mc:AlternateContent xmlns:mc="http://schemas.openxmlformats.org/markup-compatibility/2006" xmlns:p159="http://schemas.microsoft.com/office/powerpoint/2015/09/main">
-    <mc:Choice Requires="p159">
-      <p:transition xmlns:p14="http://schemas.microsoft.com/office/powerpoint/2010/main" spd="slow" p14:dur="2000">
-        <p159:morph option="byObject"/>
-      </p:transition>
-    </mc:Choice>
-    <mc:Fallback xmlns="">
-      <p:transition spd="slow">
-        <p:fade/>
-      </p:transition>
-    </mc:Fallback>
-  </mc:AlternateContent>
-</p:sld>
-</file>
-
-<file path=ppt/slides/slide11.xml><?xml version="1.0" encoding="utf-8"?>
-<p:sld xmlns:a="http://schemas.openxmlformats.org/drawingml/2006/main" xmlns:r="http://schemas.openxmlformats.org/officeDocument/2006/relationships" xmlns:p="http://schemas.openxmlformats.org/presentationml/2006/main">
-  <p:cSld>
-    <p:spTree>
-      <p:nvGrpSpPr>
-        <p:cNvPr id="1" name=""/>
-        <p:cNvGrpSpPr/>
-        <p:nvPr/>
-      </p:nvGrpSpPr>
-      <p:grpSpPr>
-        <a:xfrm>
-          <a:off x="0" y="0"/>
-          <a:ext cx="0" cy="0"/>
-          <a:chOff x="0" y="0"/>
-          <a:chExt cx="0" cy="0"/>
-        </a:xfrm>
-      </p:grpSpPr>
-      <p:sp>
-        <p:nvSpPr>
-          <p:cNvPr id="2" name="Заголовок 1">
-            <a:extLst>
-              <a:ext uri="{FF2B5EF4-FFF2-40B4-BE49-F238E27FC236}">
-                <a16:creationId xmlns:a16="http://schemas.microsoft.com/office/drawing/2014/main" id="{7D943821-AECF-4A55-8E12-49D7F394EDD7}"/>
-              </a:ext>
-            </a:extLst>
-          </p:cNvPr>
-          <p:cNvSpPr>
-            <a:spLocks noGrp="1"/>
-          </p:cNvSpPr>
-          <p:nvPr>
-            <p:ph type="title"/>
-          </p:nvPr>
-        </p:nvSpPr>
-        <p:spPr>
-          <a:xfrm>
-            <a:off x="1359408" y="2766218"/>
-            <a:ext cx="8900160" cy="1325563"/>
-          </a:xfrm>
-        </p:spPr>
-        <p:txBody>
-          <a:bodyPr/>
-          <a:lstStyle/>
-          <a:p>
-            <a:r>
-              <a:rPr lang="ru-RU" dirty="0"/>
-              <a:t>Спасибо за внимание!</a:t>
-            </a:r>
-          </a:p>
-        </p:txBody>
-      </p:sp>
-      <p:pic>
-        <p:nvPicPr>
-          <p:cNvPr id="4" name="Picture 3" descr="A qr code with a few black squares&#10;&#10;AI-generated content may be incorrect.">
-            <a:extLst>
-              <a:ext uri="{FF2B5EF4-FFF2-40B4-BE49-F238E27FC236}">
-                <a16:creationId xmlns:a16="http://schemas.microsoft.com/office/drawing/2014/main" id="{1BCFA2C3-0497-CAA5-FD7A-A8CB123723AA}"/>
-              </a:ext>
-            </a:extLst>
-          </p:cNvPr>
-          <p:cNvPicPr>
-            <a:picLocks noChangeAspect="1"/>
-          </p:cNvPicPr>
-          <p:nvPr/>
-        </p:nvPicPr>
-        <p:blipFill>
-          <a:blip r:embed="rId2">
-            <a:extLst>
-              <a:ext uri="{28A0092B-C50C-407E-A947-70E740481C1C}">
-                <a14:useLocalDpi xmlns:a14="http://schemas.microsoft.com/office/drawing/2010/main" val="0"/>
-              </a:ext>
-            </a:extLst>
-          </a:blip>
-          <a:stretch>
-            <a:fillRect/>
-          </a:stretch>
-        </p:blipFill>
-        <p:spPr>
-          <a:xfrm>
-            <a:off x="7709338" y="1187668"/>
-            <a:ext cx="4482662" cy="4482662"/>
-          </a:xfrm>
-          <a:prstGeom prst="rect">
-            <a:avLst/>
-          </a:prstGeom>
-        </p:spPr>
-      </p:pic>
-      <p:sp>
-        <p:nvSpPr>
-          <p:cNvPr id="5" name="TextBox 4">
-            <a:extLst>
-              <a:ext uri="{FF2B5EF4-FFF2-40B4-BE49-F238E27FC236}">
-                <a16:creationId xmlns:a16="http://schemas.microsoft.com/office/drawing/2014/main" id="{4C3BFE98-C350-885B-94B0-F90C27C73478}"/>
-              </a:ext>
-            </a:extLst>
-          </p:cNvPr>
-          <p:cNvSpPr txBox="1"/>
-          <p:nvPr/>
-        </p:nvSpPr>
-        <p:spPr>
-          <a:xfrm>
-            <a:off x="9268431" y="818336"/>
-            <a:ext cx="1364476" cy="369332"/>
-          </a:xfrm>
-          <a:prstGeom prst="rect">
-            <a:avLst/>
-          </a:prstGeom>
-          <a:noFill/>
-        </p:spPr>
-        <p:txBody>
-          <a:bodyPr wrap="none" rtlCol="0">
-            <a:spAutoFit/>
-          </a:bodyPr>
-          <a:lstStyle/>
-          <a:p>
-            <a:r>
-              <a:rPr lang="ru-RU" dirty="0"/>
-              <a:t>Наш </a:t>
-            </a:r>
-            <a:r>
-              <a:rPr lang="en-US" dirty="0" err="1"/>
-              <a:t>Github</a:t>
-            </a:r>
-            <a:r>
-              <a:rPr lang="en-US" dirty="0"/>
-              <a:t>:</a:t>
-            </a:r>
-          </a:p>
-        </p:txBody>
-      </p:sp>
-      <p:pic>
-        <p:nvPicPr>
-          <p:cNvPr id="2052" name="Picture 4" descr="Gnu logo - Free Icon PNG, SVG">
-            <a:extLst>
-              <a:ext uri="{FF2B5EF4-FFF2-40B4-BE49-F238E27FC236}">
-                <a16:creationId xmlns:a16="http://schemas.microsoft.com/office/drawing/2014/main" id="{393C2445-745E-64E0-6EE1-CAB0D4221B88}"/>
-              </a:ext>
-            </a:extLst>
-          </p:cNvPr>
-          <p:cNvPicPr>
-            <a:picLocks noChangeAspect="1" noChangeArrowheads="1"/>
-          </p:cNvPicPr>
-          <p:nvPr/>
-        </p:nvPicPr>
-        <p:blipFill>
-          <a:blip r:embed="rId3">
-            <a:extLst>
-              <a:ext uri="{28A0092B-C50C-407E-A947-70E740481C1C}">
-                <a14:useLocalDpi xmlns:a14="http://schemas.microsoft.com/office/drawing/2010/main" val="0"/>
-              </a:ext>
-            </a:extLst>
-          </a:blip>
-          <a:srcRect/>
-          <a:stretch>
-            <a:fillRect/>
-          </a:stretch>
-        </p:blipFill>
-        <p:spPr bwMode="auto">
-          <a:xfrm>
-            <a:off x="21967" y="5532435"/>
-            <a:ext cx="1337441" cy="1337441"/>
-          </a:xfrm>
-          <a:prstGeom prst="rect">
-            <a:avLst/>
-          </a:prstGeom>
-          <a:noFill/>
-          <a:extLst>
-            <a:ext uri="{909E8E84-426E-40DD-AFC4-6F175D3DCCD1}">
-              <a14:hiddenFill xmlns:a14="http://schemas.microsoft.com/office/drawing/2010/main">
-                <a:solidFill>
-                  <a:srgbClr val="FFFFFF"/>
-                </a:solidFill>
-              </a14:hiddenFill>
-            </a:ext>
-          </a:extLst>
-        </p:spPr>
-      </p:pic>
-    </p:spTree>
-    <p:extLst>
-      <p:ext uri="{BB962C8B-B14F-4D97-AF65-F5344CB8AC3E}">
-        <p14:creationId xmlns:p14="http://schemas.microsoft.com/office/powerpoint/2010/main" val="419338050"/>
-      </p:ext>
-    </p:extLst>
-  </p:cSld>
-  <p:clrMapOvr>
-    <a:masterClrMapping/>
-  </p:clrMapOvr>
-  <mc:AlternateContent xmlns:mc="http://schemas.openxmlformats.org/markup-compatibility/2006" xmlns:p159="http://schemas.microsoft.com/office/powerpoint/2015/09/main">
-    <mc:Choice Requires="p159">
-      <p:transition xmlns:p14="http://schemas.microsoft.com/office/powerpoint/2010/main" spd="slow" p14:dur="2000">
-        <p159:morph option="byObject"/>
-      </p:transition>
-    </mc:Choice>
-    <mc:Fallback xmlns="">
-      <p:transition spd="slow">
-        <p:fade/>
-      </p:transition>
-    </mc:Fallback>
-  </mc:AlternateContent>
-</p:sld>
-</file>
-
 <file path=ppt/slides/slide2.xml><?xml version="1.0" encoding="utf-8"?>
-<p:sld xmlns:a="http://schemas.openxmlformats.org/drawingml/2006/main" xmlns:r="http://schemas.openxmlformats.org/officeDocument/2006/relationships" xmlns:p="http://schemas.openxmlformats.org/presentationml/2006/main">
-  <p:cSld>
-    <p:spTree>
-      <p:nvGrpSpPr>
-        <p:cNvPr id="1" name=""/>
-        <p:cNvGrpSpPr/>
-        <p:nvPr/>
-      </p:nvGrpSpPr>
-      <p:grpSpPr>
-        <a:xfrm>
-          <a:off x="0" y="0"/>
-          <a:ext cx="0" cy="0"/>
-          <a:chOff x="0" y="0"/>
-          <a:chExt cx="0" cy="0"/>
-        </a:xfrm>
-      </p:grpSpPr>
-      <p:sp>
-        <p:nvSpPr>
-          <p:cNvPr id="2" name="Title 1">
-            <a:extLst>
-              <a:ext uri="{FF2B5EF4-FFF2-40B4-BE49-F238E27FC236}">
-                <a16:creationId xmlns:a16="http://schemas.microsoft.com/office/drawing/2014/main" id="{681377DB-DA89-2D4D-F7B5-51AD22439D9F}"/>
-              </a:ext>
-            </a:extLst>
-          </p:cNvPr>
-          <p:cNvSpPr>
-            <a:spLocks noGrp="1"/>
-          </p:cNvSpPr>
-          <p:nvPr>
-            <p:ph type="title"/>
-          </p:nvPr>
-        </p:nvSpPr>
-        <p:spPr>
-          <a:xfrm>
-            <a:off x="4929808" y="0"/>
-            <a:ext cx="2332383" cy="1325563"/>
-          </a:xfrm>
-        </p:spPr>
-        <p:txBody>
-          <a:bodyPr/>
-          <a:lstStyle/>
-          <a:p>
-            <a:r>
-              <a:rPr lang="ru-RU" dirty="0"/>
-              <a:t>Команда</a:t>
-            </a:r>
-            <a:endParaRPr lang="en-US" dirty="0"/>
-          </a:p>
-        </p:txBody>
-      </p:sp>
-      <p:sp>
-        <p:nvSpPr>
-          <p:cNvPr id="3" name="TextBox 2">
-            <a:extLst>
-              <a:ext uri="{FF2B5EF4-FFF2-40B4-BE49-F238E27FC236}">
-                <a16:creationId xmlns:a16="http://schemas.microsoft.com/office/drawing/2014/main" id="{CDC2A55D-7927-3EF5-2CB4-F0F4137ECA62}"/>
-              </a:ext>
-            </a:extLst>
-          </p:cNvPr>
-          <p:cNvSpPr txBox="1"/>
-          <p:nvPr/>
-        </p:nvSpPr>
-        <p:spPr>
-          <a:xfrm>
-            <a:off x="659297" y="5460963"/>
-            <a:ext cx="3180521" cy="923330"/>
-          </a:xfrm>
-          <a:prstGeom prst="rect">
-            <a:avLst/>
-          </a:prstGeom>
-          <a:noFill/>
-        </p:spPr>
-        <p:txBody>
-          <a:bodyPr wrap="square" rtlCol="0">
-            <a:spAutoFit/>
-          </a:bodyPr>
-          <a:lstStyle/>
-          <a:p>
-            <a:r>
-              <a:rPr lang="ru-RU" dirty="0"/>
-              <a:t>Лидер проекта. Писал программу, согласовывал работу.</a:t>
-            </a:r>
-            <a:endParaRPr lang="en-US" dirty="0"/>
-          </a:p>
-        </p:txBody>
-      </p:sp>
-      <p:sp>
-        <p:nvSpPr>
-          <p:cNvPr id="4" name="TextBox 3">
-            <a:extLst>
-              <a:ext uri="{FF2B5EF4-FFF2-40B4-BE49-F238E27FC236}">
-                <a16:creationId xmlns:a16="http://schemas.microsoft.com/office/drawing/2014/main" id="{F11F4743-C488-DA7C-6185-94C5000AE3D2}"/>
-              </a:ext>
-            </a:extLst>
-          </p:cNvPr>
-          <p:cNvSpPr txBox="1"/>
-          <p:nvPr/>
-        </p:nvSpPr>
-        <p:spPr>
-          <a:xfrm>
-            <a:off x="4714462" y="5460963"/>
-            <a:ext cx="2547729" cy="646331"/>
-          </a:xfrm>
-          <a:prstGeom prst="rect">
-            <a:avLst/>
-          </a:prstGeom>
-          <a:noFill/>
-        </p:spPr>
-        <p:txBody>
-          <a:bodyPr wrap="square" rtlCol="0">
-            <a:spAutoFit/>
-          </a:bodyPr>
-          <a:lstStyle/>
-          <a:p>
-            <a:r>
-              <a:rPr lang="ru-RU" dirty="0"/>
-              <a:t>Тестировщик, помогал в написании программы</a:t>
-            </a:r>
-            <a:endParaRPr lang="en-US" dirty="0"/>
-          </a:p>
-        </p:txBody>
-      </p:sp>
-      <p:sp>
-        <p:nvSpPr>
-          <p:cNvPr id="5" name="TextBox 4">
-            <a:extLst>
-              <a:ext uri="{FF2B5EF4-FFF2-40B4-BE49-F238E27FC236}">
-                <a16:creationId xmlns:a16="http://schemas.microsoft.com/office/drawing/2014/main" id="{D6818099-06BD-21B2-2805-14069CC323D2}"/>
-              </a:ext>
-            </a:extLst>
-          </p:cNvPr>
-          <p:cNvSpPr txBox="1"/>
-          <p:nvPr/>
-        </p:nvSpPr>
-        <p:spPr>
-          <a:xfrm>
-            <a:off x="8352183" y="5468991"/>
-            <a:ext cx="3180521" cy="923330"/>
-          </a:xfrm>
-          <a:prstGeom prst="rect">
-            <a:avLst/>
-          </a:prstGeom>
-          <a:noFill/>
-        </p:spPr>
-        <p:txBody>
-          <a:bodyPr wrap="square" rtlCol="0">
-            <a:spAutoFit/>
-          </a:bodyPr>
-          <a:lstStyle/>
-          <a:p>
-            <a:r>
-              <a:rPr lang="ru-RU" dirty="0"/>
-              <a:t>Копирайтер. Создатель документации и большей части презентации, </a:t>
-            </a:r>
-            <a:endParaRPr lang="en-US" dirty="0"/>
-          </a:p>
-        </p:txBody>
-      </p:sp>
-      <p:sp>
-        <p:nvSpPr>
-          <p:cNvPr id="8" name="TextBox 7">
-            <a:extLst>
-              <a:ext uri="{FF2B5EF4-FFF2-40B4-BE49-F238E27FC236}">
-                <a16:creationId xmlns:a16="http://schemas.microsoft.com/office/drawing/2014/main" id="{10AD6EA3-5097-C6F8-D5E5-B5133CE72B7B}"/>
-              </a:ext>
-            </a:extLst>
-          </p:cNvPr>
-          <p:cNvSpPr txBox="1"/>
-          <p:nvPr/>
-        </p:nvSpPr>
-        <p:spPr>
-          <a:xfrm>
-            <a:off x="8791326" y="2802834"/>
-            <a:ext cx="2302233" cy="461665"/>
-          </a:xfrm>
-          <a:prstGeom prst="rect">
-            <a:avLst/>
-          </a:prstGeom>
-          <a:noFill/>
-        </p:spPr>
-        <p:txBody>
-          <a:bodyPr wrap="none" rtlCol="0">
-            <a:spAutoFit/>
-          </a:bodyPr>
-          <a:lstStyle/>
-          <a:p>
-            <a:r>
-              <a:rPr lang="ru-RU" sz="2400" dirty="0"/>
-              <a:t>Иван Чернышов</a:t>
-            </a:r>
-            <a:endParaRPr lang="en-US" sz="2400" dirty="0"/>
-          </a:p>
-        </p:txBody>
-      </p:sp>
-      <p:sp>
-        <p:nvSpPr>
-          <p:cNvPr id="9" name="TextBox 8">
-            <a:extLst>
-              <a:ext uri="{FF2B5EF4-FFF2-40B4-BE49-F238E27FC236}">
-                <a16:creationId xmlns:a16="http://schemas.microsoft.com/office/drawing/2014/main" id="{A65EE43A-CA26-7BEF-ECBF-54FEAFCFB64B}"/>
-              </a:ext>
-            </a:extLst>
-          </p:cNvPr>
-          <p:cNvSpPr txBox="1"/>
-          <p:nvPr/>
-        </p:nvSpPr>
-        <p:spPr>
-          <a:xfrm>
-            <a:off x="4846778" y="2802834"/>
-            <a:ext cx="2498441" cy="461665"/>
-          </a:xfrm>
-          <a:prstGeom prst="rect">
-            <a:avLst/>
-          </a:prstGeom>
-          <a:noFill/>
-        </p:spPr>
-        <p:txBody>
-          <a:bodyPr wrap="none" rtlCol="0">
-            <a:spAutoFit/>
-          </a:bodyPr>
-          <a:lstStyle/>
-          <a:p>
-            <a:r>
-              <a:rPr lang="ru-RU" sz="2400" dirty="0"/>
-              <a:t>Данила Атаманов</a:t>
-            </a:r>
-            <a:endParaRPr lang="en-US" sz="2400" dirty="0"/>
-          </a:p>
-        </p:txBody>
-      </p:sp>
-      <p:sp>
-        <p:nvSpPr>
-          <p:cNvPr id="10" name="TextBox 9">
-            <a:extLst>
-              <a:ext uri="{FF2B5EF4-FFF2-40B4-BE49-F238E27FC236}">
-                <a16:creationId xmlns:a16="http://schemas.microsoft.com/office/drawing/2014/main" id="{CB45755A-4400-CCD8-978F-5974BA96C63D}"/>
-              </a:ext>
-            </a:extLst>
-          </p:cNvPr>
-          <p:cNvSpPr txBox="1"/>
-          <p:nvPr/>
-        </p:nvSpPr>
-        <p:spPr>
-          <a:xfrm>
-            <a:off x="1186894" y="2802834"/>
-            <a:ext cx="2125325" cy="461665"/>
-          </a:xfrm>
-          <a:prstGeom prst="rect">
-            <a:avLst/>
-          </a:prstGeom>
-          <a:noFill/>
-        </p:spPr>
-        <p:txBody>
-          <a:bodyPr wrap="none" rtlCol="0">
-            <a:spAutoFit/>
-          </a:bodyPr>
-          <a:lstStyle/>
-          <a:p>
-            <a:r>
-              <a:rPr lang="ru-RU" sz="2400" dirty="0"/>
-              <a:t>Богдан Планов</a:t>
-            </a:r>
-            <a:endParaRPr lang="en-US" sz="2400" dirty="0"/>
-          </a:p>
-        </p:txBody>
-      </p:sp>
-    </p:spTree>
-    <p:extLst>
-      <p:ext uri="{BB962C8B-B14F-4D97-AF65-F5344CB8AC3E}">
-        <p14:creationId xmlns:p14="http://schemas.microsoft.com/office/powerpoint/2010/main" val="2410697179"/>
-      </p:ext>
-    </p:extLst>
-  </p:cSld>
-  <p:clrMapOvr>
-    <a:masterClrMapping/>
-  </p:clrMapOvr>
-  <mc:AlternateContent xmlns:mc="http://schemas.openxmlformats.org/markup-compatibility/2006" xmlns:p159="http://schemas.microsoft.com/office/powerpoint/2015/09/main">
-    <mc:Choice Requires="p159">
-      <p:transition xmlns:p14="http://schemas.microsoft.com/office/powerpoint/2010/main" spd="slow" p14:dur="2000">
-        <p159:morph option="byObject"/>
-      </p:transition>
-    </mc:Choice>
-    <mc:Fallback xmlns="">
-      <p:transition spd="slow">
-        <p:fade/>
-      </p:transition>
-    </mc:Fallback>
-  </mc:AlternateContent>
-</p:sld>
-</file>
-
-<file path=ppt/slides/slide3.xml><?xml version="1.0" encoding="utf-8"?>
-<p:sld xmlns:a="http://schemas.openxmlformats.org/drawingml/2006/main" xmlns:r="http://schemas.openxmlformats.org/officeDocument/2006/relationships" xmlns:p="http://schemas.openxmlformats.org/presentationml/2006/main">
-  <p:cSld>
-    <p:spTree>
-      <p:nvGrpSpPr>
-        <p:cNvPr id="1" name=""/>
-        <p:cNvGrpSpPr/>
-        <p:nvPr/>
-      </p:nvGrpSpPr>
-      <p:grpSpPr>
-        <a:xfrm>
-          <a:off x="0" y="0"/>
-          <a:ext cx="0" cy="0"/>
-          <a:chOff x="0" y="0"/>
-          <a:chExt cx="0" cy="0"/>
-        </a:xfrm>
-      </p:grpSpPr>
-      <p:sp>
-        <p:nvSpPr>
-          <p:cNvPr id="2" name="Title 1">
-            <a:extLst>
-              <a:ext uri="{FF2B5EF4-FFF2-40B4-BE49-F238E27FC236}">
-                <a16:creationId xmlns:a16="http://schemas.microsoft.com/office/drawing/2014/main" id="{D3A5D700-CE6E-3050-0764-52CB5B25BF24}"/>
-              </a:ext>
-            </a:extLst>
-          </p:cNvPr>
-          <p:cNvSpPr>
-            <a:spLocks noGrp="1"/>
-          </p:cNvSpPr>
-          <p:nvPr>
-            <p:ph type="title"/>
-          </p:nvPr>
-        </p:nvSpPr>
-        <p:spPr>
-          <a:xfrm>
-            <a:off x="4838085" y="0"/>
-            <a:ext cx="2515829" cy="668594"/>
-          </a:xfrm>
-        </p:spPr>
-        <p:txBody>
-          <a:bodyPr>
-            <a:normAutofit fontScale="90000"/>
-          </a:bodyPr>
-          <a:lstStyle/>
-          <a:p>
-            <a:r>
-              <a:rPr lang="ru-RU" dirty="0"/>
-              <a:t>Аннотация</a:t>
-            </a:r>
-            <a:endParaRPr lang="en-US" dirty="0"/>
-          </a:p>
-        </p:txBody>
-      </p:sp>
-      <p:sp>
-        <p:nvSpPr>
-          <p:cNvPr id="3" name="TextBox 2">
-            <a:extLst>
-              <a:ext uri="{FF2B5EF4-FFF2-40B4-BE49-F238E27FC236}">
-                <a16:creationId xmlns:a16="http://schemas.microsoft.com/office/drawing/2014/main" id="{99A942A6-8CB4-7B23-2DDE-C1535920952E}"/>
-              </a:ext>
-            </a:extLst>
-          </p:cNvPr>
-          <p:cNvSpPr txBox="1"/>
-          <p:nvPr/>
-        </p:nvSpPr>
-        <p:spPr>
-          <a:xfrm>
-            <a:off x="1637068" y="668594"/>
-            <a:ext cx="8917859" cy="2462213"/>
-          </a:xfrm>
-          <a:prstGeom prst="rect">
-            <a:avLst/>
-          </a:prstGeom>
-          <a:noFill/>
-        </p:spPr>
-        <p:txBody>
-          <a:bodyPr wrap="square" rtlCol="0">
-            <a:spAutoFit/>
-          </a:bodyPr>
-          <a:lstStyle/>
-          <a:p>
-            <a:r>
-              <a:rPr lang="ru-RU" sz="2200" dirty="0"/>
-              <a:t>Наша программа (</a:t>
-            </a:r>
-            <a:r>
-              <a:rPr lang="en-US" sz="2200" dirty="0" err="1"/>
-              <a:t>pdd</a:t>
-            </a:r>
-            <a:r>
-              <a:rPr lang="en-US" sz="2200" dirty="0"/>
-              <a:t> – professional disk diagnostic</a:t>
-            </a:r>
-            <a:r>
-              <a:rPr lang="ru-RU" sz="2200" dirty="0"/>
-              <a:t>)</a:t>
-            </a:r>
-            <a:r>
-              <a:rPr lang="en-US" sz="2200" dirty="0"/>
-              <a:t> </a:t>
-            </a:r>
-            <a:r>
-              <a:rPr lang="ru-RU" sz="2200" dirty="0"/>
-              <a:t>предназначена для глубокой диагностики накопителей (</a:t>
-            </a:r>
-            <a:r>
-              <a:rPr lang="en-US" sz="2200" dirty="0"/>
-              <a:t>HDD, SSD, NVME, Flash</a:t>
-            </a:r>
-            <a:r>
-              <a:rPr lang="ru-RU" sz="2200" dirty="0"/>
-              <a:t>)</a:t>
-            </a:r>
-            <a:r>
-              <a:rPr lang="en-US" sz="2200" dirty="0"/>
-              <a:t>. </a:t>
-            </a:r>
-            <a:r>
-              <a:rPr lang="ru-RU" sz="2200" dirty="0"/>
-              <a:t>Она может вывести подробную информацию о дисковой подсистеме (конфигурация, температура, ошибки ввода/вывода), замерить скорость чтения/записи, провести проверку на битые сектора, проанализировать использование места на диске, отформатировать его. Работает из терминала и устанавливается одной командой.</a:t>
-            </a:r>
-            <a:endParaRPr lang="en-US" sz="2200" dirty="0"/>
-          </a:p>
-        </p:txBody>
-      </p:sp>
-      <p:sp>
-        <p:nvSpPr>
-          <p:cNvPr id="4" name="TextBox 3">
-            <a:extLst>
-              <a:ext uri="{FF2B5EF4-FFF2-40B4-BE49-F238E27FC236}">
-                <a16:creationId xmlns:a16="http://schemas.microsoft.com/office/drawing/2014/main" id="{74A15736-758F-5A3F-9C4B-6DCB10CD5F0F}"/>
-              </a:ext>
-            </a:extLst>
-          </p:cNvPr>
-          <p:cNvSpPr txBox="1"/>
-          <p:nvPr/>
-        </p:nvSpPr>
-        <p:spPr>
-          <a:xfrm>
-            <a:off x="1637067" y="3727194"/>
-            <a:ext cx="8917859" cy="769441"/>
-          </a:xfrm>
-          <a:prstGeom prst="rect">
-            <a:avLst/>
-          </a:prstGeom>
-          <a:noFill/>
-        </p:spPr>
-        <p:txBody>
-          <a:bodyPr wrap="square" rtlCol="0">
-            <a:spAutoFit/>
-          </a:bodyPr>
-          <a:lstStyle/>
-          <a:p>
-            <a:r>
-              <a:rPr lang="ru-RU" sz="2200" dirty="0"/>
-              <a:t>Ожидаемая аудитория: системные администраторы ПК с </a:t>
-            </a:r>
-            <a:r>
-              <a:rPr lang="en-US" sz="2200" dirty="0"/>
-              <a:t>Linux, </a:t>
-            </a:r>
-            <a:r>
-              <a:rPr lang="ru-RU" sz="2200" dirty="0"/>
-              <a:t>пользователи </a:t>
-            </a:r>
-            <a:r>
-              <a:rPr lang="en-US" sz="2200" dirty="0"/>
-              <a:t>UNIX-</a:t>
-            </a:r>
-            <a:r>
-              <a:rPr lang="ru-RU" sz="2200" dirty="0"/>
-              <a:t>подобных ОС</a:t>
-            </a:r>
-            <a:endParaRPr lang="en-US" sz="2200" dirty="0"/>
-          </a:p>
-        </p:txBody>
-      </p:sp>
-      <p:pic>
-        <p:nvPicPr>
-          <p:cNvPr id="1026" name="Picture 2" descr="Почему linux должен быть единственной системой в образовательном процессе /  Хабр">
-            <a:extLst>
-              <a:ext uri="{FF2B5EF4-FFF2-40B4-BE49-F238E27FC236}">
-                <a16:creationId xmlns:a16="http://schemas.microsoft.com/office/drawing/2014/main" id="{BD5A62D2-676F-15C0-B4B3-8FAFA5B12D5C}"/>
-              </a:ext>
-            </a:extLst>
-          </p:cNvPr>
-          <p:cNvPicPr>
-            <a:picLocks noChangeAspect="1" noChangeArrowheads="1"/>
-          </p:cNvPicPr>
-          <p:nvPr/>
-        </p:nvPicPr>
-        <p:blipFill>
-          <a:blip r:embed="rId2">
-            <a:extLst>
-              <a:ext uri="{28A0092B-C50C-407E-A947-70E740481C1C}">
-                <a14:useLocalDpi xmlns:a14="http://schemas.microsoft.com/office/drawing/2010/main" val="0"/>
-              </a:ext>
-            </a:extLst>
-          </a:blip>
-          <a:srcRect/>
-          <a:stretch>
-            <a:fillRect/>
-          </a:stretch>
-        </p:blipFill>
-        <p:spPr bwMode="auto">
-          <a:xfrm>
-            <a:off x="3957404" y="4496635"/>
-            <a:ext cx="4277191" cy="2361365"/>
-          </a:xfrm>
-          <a:prstGeom prst="rect">
-            <a:avLst/>
-          </a:prstGeom>
-          <a:noFill/>
-          <a:extLst>
-            <a:ext uri="{909E8E84-426E-40DD-AFC4-6F175D3DCCD1}">
-              <a14:hiddenFill xmlns:a14="http://schemas.microsoft.com/office/drawing/2010/main">
-                <a:solidFill>
-                  <a:srgbClr val="FFFFFF"/>
-                </a:solidFill>
-              </a14:hiddenFill>
-            </a:ext>
-          </a:extLst>
-        </p:spPr>
-      </p:pic>
-    </p:spTree>
-    <p:extLst>
-      <p:ext uri="{BB962C8B-B14F-4D97-AF65-F5344CB8AC3E}">
-        <p14:creationId xmlns:p14="http://schemas.microsoft.com/office/powerpoint/2010/main" val="4052126513"/>
-      </p:ext>
-    </p:extLst>
-  </p:cSld>
-  <p:clrMapOvr>
-    <a:masterClrMapping/>
-  </p:clrMapOvr>
-  <mc:AlternateContent xmlns:mc="http://schemas.openxmlformats.org/markup-compatibility/2006" xmlns:p159="http://schemas.microsoft.com/office/powerpoint/2015/09/main">
-    <mc:Choice Requires="p159">
-      <p:transition xmlns:p14="http://schemas.microsoft.com/office/powerpoint/2010/main" spd="slow" p14:dur="2000">
-        <p159:morph option="byObject"/>
-      </p:transition>
-    </mc:Choice>
-    <mc:Fallback xmlns="">
-      <p:transition spd="slow">
-        <p:fade/>
-      </p:transition>
-    </mc:Fallback>
-  </mc:AlternateContent>
-</p:sld>
-</file>
-
-<file path=ppt/slides/slide4.xml><?xml version="1.0" encoding="utf-8"?>
 <p:sld xmlns:a="http://schemas.openxmlformats.org/drawingml/2006/main" xmlns:r="http://schemas.openxmlformats.org/officeDocument/2006/relationships" xmlns:p="http://schemas.openxmlformats.org/presentationml/2006/main">
   <p:cSld>
     <p:spTree>
@@ -4863,7 +3882,7 @@
 </p:sld>
 </file>
 
-<file path=ppt/slides/slide5.xml><?xml version="1.0" encoding="utf-8"?>
+<file path=ppt/slides/slide3.xml><?xml version="1.0" encoding="utf-8"?>
 <p:sld xmlns:a="http://schemas.openxmlformats.org/drawingml/2006/main" xmlns:r="http://schemas.openxmlformats.org/officeDocument/2006/relationships" xmlns:p="http://schemas.openxmlformats.org/presentationml/2006/main">
   <p:cSld>
     <p:spTree>
@@ -4978,7 +3997,7 @@
 </p:sld>
 </file>
 
-<file path=ppt/slides/slide6.xml><?xml version="1.0" encoding="utf-8"?>
+<file path=ppt/slides/slide4.xml><?xml version="1.0" encoding="utf-8"?>
 <p:sld xmlns:a="http://schemas.openxmlformats.org/drawingml/2006/main" xmlns:r="http://schemas.openxmlformats.org/officeDocument/2006/relationships" xmlns:p="http://schemas.openxmlformats.org/presentationml/2006/main">
   <p:cSld>
     <p:spTree>
@@ -5019,42 +4038,45 @@
         </p:spPr>
         <p:txBody>
           <a:bodyPr>
-            <a:normAutofit lnSpcReduction="10000"/>
+            <a:normAutofit/>
           </a:bodyPr>
           <a:lstStyle/>
           <a:p>
             <a:r>
               <a:rPr lang="ru-RU" sz="2400" dirty="0"/>
-              <a:t>1) Создать программу, совмещающую в себе несколько других</a:t>
+              <a:t>1) Изучить служебные программы в различных ОС</a:t>
             </a:r>
             <a:endParaRPr lang="en-US" sz="2400" dirty="0"/>
           </a:p>
           <a:p>
             <a:r>
               <a:rPr lang="ru-RU" sz="2400" dirty="0"/>
-              <a:t>2) Использовать только стандартные инструменты</a:t>
+              <a:t>2) Написать код, основывающийся на стандартных инструментах </a:t>
+            </a:r>
+            <a:r>
+              <a:rPr lang="en-US" sz="2400" dirty="0"/>
+              <a:t>Linux</a:t>
+            </a:r>
+          </a:p>
+          <a:p>
+            <a:r>
+              <a:rPr lang="ru-RU" sz="2400" dirty="0"/>
+              <a:t>3) Провести тестирование программы</a:t>
             </a:r>
             <a:endParaRPr lang="en-US" sz="2400" dirty="0"/>
           </a:p>
           <a:p>
             <a:r>
               <a:rPr lang="ru-RU" sz="2400" dirty="0"/>
-              <a:t>3) Убрать лишнее, оставив только функционал</a:t>
+              <a:t>4) Оптимизировать код программы</a:t>
+            </a:r>
+          </a:p>
+          <a:p>
+            <a:r>
+              <a:rPr lang="ru-RU" sz="2400" dirty="0"/>
+              <a:t>5) Сделать правки для облегчения портирования на UNIX-подобные ОС</a:t>
             </a:r>
             <a:endParaRPr lang="en-US" sz="2400" dirty="0"/>
-          </a:p>
-          <a:p>
-            <a:r>
-              <a:rPr lang="ru-RU" sz="2400" dirty="0"/>
-              <a:t>4) Сделать программу легкой в портировании на UNIX-подобные ОС</a:t>
-            </a:r>
-            <a:endParaRPr lang="en-US" sz="2400" dirty="0"/>
-          </a:p>
-          <a:p>
-            <a:r>
-              <a:rPr lang="ru-RU" sz="2400" dirty="0"/>
-              <a:t>5) Разнообразить выбор подобных программ</a:t>
-            </a:r>
           </a:p>
         </p:txBody>
       </p:sp>
@@ -5155,7 +4177,7 @@
 </p:sld>
 </file>
 
-<file path=ppt/slides/slide7.xml><?xml version="1.0" encoding="utf-8"?>
+<file path=ppt/slides/slide5.xml><?xml version="1.0" encoding="utf-8"?>
 <p:sld xmlns:a="http://schemas.openxmlformats.org/drawingml/2006/main" xmlns:r="http://schemas.openxmlformats.org/officeDocument/2006/relationships" xmlns:p="http://schemas.openxmlformats.org/presentationml/2006/main">
   <p:cSld>
     <p:spTree>
@@ -5177,7 +4199,7 @@
           <p:cNvPr id="2" name="Title 1">
             <a:extLst>
               <a:ext uri="{FF2B5EF4-FFF2-40B4-BE49-F238E27FC236}">
-                <a16:creationId xmlns:a16="http://schemas.microsoft.com/office/drawing/2014/main" id="{6C860292-E752-791B-7787-01AD560BE88A}"/>
+                <a16:creationId xmlns:a16="http://schemas.microsoft.com/office/drawing/2014/main" id="{D3A5D700-CE6E-3050-0764-52CB5B25BF24}"/>
               </a:ext>
             </a:extLst>
           </p:cNvPr>
@@ -5190,1238 +4212,199 @@
         </p:nvSpPr>
         <p:spPr>
           <a:xfrm>
-            <a:off x="4413031" y="1"/>
-            <a:ext cx="3365938" cy="777766"/>
+            <a:off x="4838085" y="0"/>
+            <a:ext cx="2515829" cy="668594"/>
           </a:xfrm>
         </p:spPr>
         <p:txBody>
-          <a:bodyPr/>
+          <a:bodyPr>
+            <a:normAutofit fontScale="90000"/>
+          </a:bodyPr>
           <a:lstStyle/>
           <a:p>
             <a:r>
-              <a:rPr lang="en-US" dirty="0"/>
-              <a:t>OTSW-</a:t>
-            </a:r>
-            <a:r>
               <a:rPr lang="ru-RU" dirty="0"/>
-              <a:t>анализ</a:t>
+              <a:t>Аннотация</a:t>
             </a:r>
             <a:endParaRPr lang="en-US" dirty="0"/>
           </a:p>
         </p:txBody>
       </p:sp>
-      <p:graphicFrame>
-        <p:nvGraphicFramePr>
-          <p:cNvPr id="3" name="Table 2">
-            <a:extLst>
-              <a:ext uri="{FF2B5EF4-FFF2-40B4-BE49-F238E27FC236}">
-                <a16:creationId xmlns:a16="http://schemas.microsoft.com/office/drawing/2014/main" id="{4296F88E-E42F-7CCD-9E91-4D79173D24A8}"/>
-              </a:ext>
-            </a:extLst>
-          </p:cNvPr>
-          <p:cNvGraphicFramePr>
-            <a:graphicFrameLocks noGrp="1"/>
-          </p:cNvGraphicFramePr>
-          <p:nvPr>
-            <p:extLst>
-              <p:ext uri="{D42A27DB-BD31-4B8C-83A1-F6EECF244321}">
-                <p14:modId xmlns:p14="http://schemas.microsoft.com/office/powerpoint/2010/main" val="3037026277"/>
-              </p:ext>
-            </p:extLst>
-          </p:nvPr>
-        </p:nvGraphicFramePr>
-        <p:xfrm>
-          <a:off x="588065" y="777767"/>
-          <a:ext cx="11015870" cy="5655994"/>
-        </p:xfrm>
-        <a:graphic>
-          <a:graphicData uri="http://schemas.openxmlformats.org/drawingml/2006/table">
-            <a:tbl>
-              <a:tblPr firstRow="1" bandRow="1">
-                <a:tableStyleId>{5C22544A-7EE6-4342-B048-85BDC9FD1C3A}</a:tableStyleId>
-              </a:tblPr>
-              <a:tblGrid>
-                <a:gridCol w="5507935">
-                  <a:extLst>
-                    <a:ext uri="{9D8B030D-6E8A-4147-A177-3AD203B41FA5}">
-                      <a16:colId xmlns:a16="http://schemas.microsoft.com/office/drawing/2014/main" val="3129542506"/>
-                    </a:ext>
-                  </a:extLst>
-                </a:gridCol>
-                <a:gridCol w="5507935">
-                  <a:extLst>
-                    <a:ext uri="{9D8B030D-6E8A-4147-A177-3AD203B41FA5}">
-                      <a16:colId xmlns:a16="http://schemas.microsoft.com/office/drawing/2014/main" val="3128442586"/>
-                    </a:ext>
-                  </a:extLst>
-                </a:gridCol>
-              </a:tblGrid>
-              <a:tr h="779010">
-                <a:tc>
-                  <a:txBody>
-                    <a:bodyPr/>
-                    <a:lstStyle/>
-                    <a:p>
-                      <a:r>
-                        <a:rPr lang="ru-RU" sz="2400" b="0" kern="0" dirty="0" err="1">
-                          <a:solidFill>
-                            <a:srgbClr val="000000"/>
-                          </a:solidFill>
-                          <a:effectLst/>
-                          <a:latin typeface="Times New Roman" panose="02020603050405020304" pitchFamily="18" charset="0"/>
-                        </a:rPr>
-                        <a:t>O</a:t>
-                      </a:r>
-                      <a:r>
-                        <a:rPr lang="ru-RU" sz="2400" b="0" kern="0" dirty="0">
-                          <a:solidFill>
-                            <a:srgbClr val="000000"/>
-                          </a:solidFill>
-                          <a:effectLst/>
-                          <a:latin typeface="Times New Roman" panose="02020603050405020304" pitchFamily="18" charset="0"/>
-                        </a:rPr>
-                        <a:t> (возможности)</a:t>
-                      </a:r>
-                      <a:endParaRPr lang="en-US" sz="2400" dirty="0"/>
-                    </a:p>
-                  </a:txBody>
-                  <a:tcPr>
-                    <a:lnL w="12700" cap="flat" cmpd="sng" algn="ctr">
-                      <a:solidFill>
-                        <a:schemeClr val="tx1"/>
-                      </a:solidFill>
-                      <a:prstDash val="solid"/>
-                      <a:round/>
-                      <a:headEnd type="none" w="med" len="med"/>
-                      <a:tailEnd type="none" w="med" len="med"/>
-                    </a:lnL>
-                    <a:lnR w="12700" cap="flat" cmpd="sng" algn="ctr">
-                      <a:solidFill>
-                        <a:schemeClr val="tx1"/>
-                      </a:solidFill>
-                      <a:prstDash val="solid"/>
-                      <a:round/>
-                      <a:headEnd type="none" w="med" len="med"/>
-                      <a:tailEnd type="none" w="med" len="med"/>
-                    </a:lnR>
-                    <a:lnT w="12700" cap="flat" cmpd="sng" algn="ctr">
-                      <a:solidFill>
-                        <a:schemeClr val="tx1"/>
-                      </a:solidFill>
-                      <a:prstDash val="solid"/>
-                      <a:round/>
-                      <a:headEnd type="none" w="med" len="med"/>
-                      <a:tailEnd type="none" w="med" len="med"/>
-                    </a:lnT>
-                    <a:lnB w="12700" cap="flat" cmpd="sng" algn="ctr">
-                      <a:solidFill>
-                        <a:schemeClr val="tx1"/>
-                      </a:solidFill>
-                      <a:prstDash val="solid"/>
-                      <a:round/>
-                      <a:headEnd type="none" w="med" len="med"/>
-                      <a:tailEnd type="none" w="med" len="med"/>
-                    </a:lnB>
-                    <a:solidFill>
-                      <a:schemeClr val="accent1"/>
-                    </a:solidFill>
-                  </a:tcPr>
-                </a:tc>
-                <a:tc>
-                  <a:txBody>
-                    <a:bodyPr/>
-                    <a:lstStyle/>
-                    <a:p>
-                      <a:r>
-                        <a:rPr lang="ru-RU" sz="2400" b="0" kern="0" dirty="0" err="1">
-                          <a:solidFill>
-                            <a:srgbClr val="000000"/>
-                          </a:solidFill>
-                          <a:effectLst/>
-                          <a:latin typeface="Times New Roman" panose="02020603050405020304" pitchFamily="18" charset="0"/>
-                        </a:rPr>
-                        <a:t>T</a:t>
-                      </a:r>
-                      <a:r>
-                        <a:rPr lang="ru-RU" sz="2400" b="0" kern="0" dirty="0">
-                          <a:solidFill>
-                            <a:srgbClr val="000000"/>
-                          </a:solidFill>
-                          <a:effectLst/>
-                          <a:latin typeface="Times New Roman" panose="02020603050405020304" pitchFamily="18" charset="0"/>
-                        </a:rPr>
-                        <a:t> (угрозы)</a:t>
-                      </a:r>
-                      <a:endParaRPr lang="en-US" sz="2400" dirty="0"/>
-                    </a:p>
-                  </a:txBody>
-                  <a:tcPr>
-                    <a:lnL w="12700" cap="flat" cmpd="sng" algn="ctr">
-                      <a:solidFill>
-                        <a:schemeClr val="tx1"/>
-                      </a:solidFill>
-                      <a:prstDash val="solid"/>
-                      <a:round/>
-                      <a:headEnd type="none" w="med" len="med"/>
-                      <a:tailEnd type="none" w="med" len="med"/>
-                    </a:lnL>
-                    <a:lnR w="12700" cap="flat" cmpd="sng" algn="ctr">
-                      <a:solidFill>
-                        <a:schemeClr val="tx1"/>
-                      </a:solidFill>
-                      <a:prstDash val="solid"/>
-                      <a:round/>
-                      <a:headEnd type="none" w="med" len="med"/>
-                      <a:tailEnd type="none" w="med" len="med"/>
-                    </a:lnR>
-                    <a:lnT w="12700" cap="flat" cmpd="sng" algn="ctr">
-                      <a:solidFill>
-                        <a:schemeClr val="tx1"/>
-                      </a:solidFill>
-                      <a:prstDash val="solid"/>
-                      <a:round/>
-                      <a:headEnd type="none" w="med" len="med"/>
-                      <a:tailEnd type="none" w="med" len="med"/>
-                    </a:lnT>
-                    <a:lnB w="12700" cap="flat" cmpd="sng" algn="ctr">
-                      <a:solidFill>
-                        <a:schemeClr val="tx1"/>
-                      </a:solidFill>
-                      <a:prstDash val="solid"/>
-                      <a:round/>
-                      <a:headEnd type="none" w="med" len="med"/>
-                      <a:tailEnd type="none" w="med" len="med"/>
-                    </a:lnB>
-                    <a:solidFill>
-                      <a:schemeClr val="accent1"/>
-                    </a:solidFill>
-                  </a:tcPr>
-                </a:tc>
-                <a:extLst>
-                  <a:ext uri="{0D108BD9-81ED-4DB2-BD59-A6C34878D82A}">
-                    <a16:rowId xmlns:a16="http://schemas.microsoft.com/office/drawing/2014/main" val="1163816623"/>
-                  </a:ext>
-                </a:extLst>
-              </a:tr>
-              <a:tr h="696712">
-                <a:tc>
-                  <a:txBody>
-                    <a:bodyPr/>
-                    <a:lstStyle/>
-                    <a:p>
-                      <a:r>
-                        <a:rPr lang="ru-RU" sz="2000" b="0" kern="0" dirty="0">
-                          <a:solidFill>
-                            <a:srgbClr val="000000"/>
-                          </a:solidFill>
-                          <a:effectLst/>
-                          <a:latin typeface="Times New Roman" panose="02020603050405020304" pitchFamily="18" charset="0"/>
-                        </a:rPr>
-                        <a:t>Разнообразие UNIX-подобных ОС</a:t>
-                      </a:r>
-                      <a:endParaRPr lang="en-US" sz="2000" dirty="0"/>
-                    </a:p>
-                  </a:txBody>
-                  <a:tcPr>
-                    <a:lnL w="12700" cap="flat" cmpd="sng" algn="ctr">
-                      <a:solidFill>
-                        <a:schemeClr val="tx1"/>
-                      </a:solidFill>
-                      <a:prstDash val="solid"/>
-                      <a:round/>
-                      <a:headEnd type="none" w="med" len="med"/>
-                      <a:tailEnd type="none" w="med" len="med"/>
-                    </a:lnL>
-                    <a:lnR w="12700" cap="flat" cmpd="sng" algn="ctr">
-                      <a:solidFill>
-                        <a:schemeClr val="tx1"/>
-                      </a:solidFill>
-                      <a:prstDash val="solid"/>
-                      <a:round/>
-                      <a:headEnd type="none" w="med" len="med"/>
-                      <a:tailEnd type="none" w="med" len="med"/>
-                    </a:lnR>
-                    <a:lnT w="12700" cap="flat" cmpd="sng" algn="ctr">
-                      <a:solidFill>
-                        <a:schemeClr val="tx1"/>
-                      </a:solidFill>
-                      <a:prstDash val="solid"/>
-                      <a:round/>
-                      <a:headEnd type="none" w="med" len="med"/>
-                      <a:tailEnd type="none" w="med" len="med"/>
-                    </a:lnT>
-                    <a:lnB w="12700" cap="flat" cmpd="sng" algn="ctr">
-                      <a:solidFill>
-                        <a:schemeClr val="tx1"/>
-                      </a:solidFill>
-                      <a:prstDash val="solid"/>
-                      <a:round/>
-                      <a:headEnd type="none" w="med" len="med"/>
-                      <a:tailEnd type="none" w="med" len="med"/>
-                    </a:lnB>
-                    <a:solidFill>
-                      <a:schemeClr val="bg1"/>
-                    </a:solidFill>
-                  </a:tcPr>
-                </a:tc>
-                <a:tc>
-                  <a:txBody>
-                    <a:bodyPr/>
-                    <a:lstStyle/>
-                    <a:p>
-                      <a:pPr marL="0" marR="0" lvl="0" indent="0" algn="l" defTabSz="914400" rtl="0" eaLnBrk="1" fontAlgn="auto" latinLnBrk="0" hangingPunct="1">
-                        <a:lnSpc>
-                          <a:spcPct val="100000"/>
-                        </a:lnSpc>
-                        <a:spcBef>
-                          <a:spcPts val="0"/>
-                        </a:spcBef>
-                        <a:spcAft>
-                          <a:spcPts val="0"/>
-                        </a:spcAft>
-                        <a:buClrTx/>
-                        <a:buSzTx/>
-                        <a:buFontTx/>
-                        <a:buNone/>
-                        <a:tabLst/>
-                        <a:defRPr/>
-                      </a:pPr>
-                      <a:r>
-                        <a:rPr lang="ru-RU" sz="2000" b="0" kern="0" dirty="0">
-                          <a:solidFill>
-                            <a:srgbClr val="000000"/>
-                          </a:solidFill>
-                          <a:effectLst/>
-                          <a:latin typeface="Times New Roman" panose="02020603050405020304" pitchFamily="18" charset="0"/>
-                        </a:rPr>
-                        <a:t>Монополия Microsoft</a:t>
-                      </a:r>
-                      <a:endParaRPr lang="en-US" sz="2000" dirty="0"/>
-                    </a:p>
-                  </a:txBody>
-                  <a:tcPr>
-                    <a:lnL w="12700" cap="flat" cmpd="sng" algn="ctr">
-                      <a:solidFill>
-                        <a:schemeClr val="tx1"/>
-                      </a:solidFill>
-                      <a:prstDash val="solid"/>
-                      <a:round/>
-                      <a:headEnd type="none" w="med" len="med"/>
-                      <a:tailEnd type="none" w="med" len="med"/>
-                    </a:lnL>
-                    <a:lnR w="12700" cap="flat" cmpd="sng" algn="ctr">
-                      <a:solidFill>
-                        <a:schemeClr val="tx1"/>
-                      </a:solidFill>
-                      <a:prstDash val="solid"/>
-                      <a:round/>
-                      <a:headEnd type="none" w="med" len="med"/>
-                      <a:tailEnd type="none" w="med" len="med"/>
-                    </a:lnR>
-                    <a:lnT w="12700" cap="flat" cmpd="sng" algn="ctr">
-                      <a:solidFill>
-                        <a:schemeClr val="tx1"/>
-                      </a:solidFill>
-                      <a:prstDash val="solid"/>
-                      <a:round/>
-                      <a:headEnd type="none" w="med" len="med"/>
-                      <a:tailEnd type="none" w="med" len="med"/>
-                    </a:lnT>
-                    <a:lnB w="12700" cap="flat" cmpd="sng" algn="ctr">
-                      <a:solidFill>
-                        <a:schemeClr val="tx1"/>
-                      </a:solidFill>
-                      <a:prstDash val="solid"/>
-                      <a:round/>
-                      <a:headEnd type="none" w="med" len="med"/>
-                      <a:tailEnd type="none" w="med" len="med"/>
-                    </a:lnB>
-                    <a:solidFill>
-                      <a:schemeClr val="bg1"/>
-                    </a:solidFill>
-                  </a:tcPr>
-                </a:tc>
-                <a:extLst>
-                  <a:ext uri="{0D108BD9-81ED-4DB2-BD59-A6C34878D82A}">
-                    <a16:rowId xmlns:a16="http://schemas.microsoft.com/office/drawing/2014/main" val="363345988"/>
-                  </a:ext>
-                </a:extLst>
-              </a:tr>
-              <a:tr h="696712">
-                <a:tc>
-                  <a:txBody>
-                    <a:bodyPr/>
-                    <a:lstStyle/>
-                    <a:p>
-                      <a:r>
-                        <a:rPr lang="ru-RU" sz="2000" b="0" kern="0" dirty="0">
-                          <a:solidFill>
-                            <a:srgbClr val="000000"/>
-                          </a:solidFill>
-                          <a:effectLst/>
-                          <a:latin typeface="Times New Roman" panose="02020603050405020304" pitchFamily="18" charset="0"/>
-                        </a:rPr>
-                        <a:t>Стандартные библиотеки GNU</a:t>
-                      </a:r>
-                      <a:endParaRPr lang="en-US" sz="2000" dirty="0"/>
-                    </a:p>
-                  </a:txBody>
-                  <a:tcPr>
-                    <a:lnL w="12700" cap="flat" cmpd="sng" algn="ctr">
-                      <a:solidFill>
-                        <a:schemeClr val="tx1"/>
-                      </a:solidFill>
-                      <a:prstDash val="solid"/>
-                      <a:round/>
-                      <a:headEnd type="none" w="med" len="med"/>
-                      <a:tailEnd type="none" w="med" len="med"/>
-                    </a:lnL>
-                    <a:lnR w="12700" cap="flat" cmpd="sng" algn="ctr">
-                      <a:solidFill>
-                        <a:schemeClr val="tx1"/>
-                      </a:solidFill>
-                      <a:prstDash val="solid"/>
-                      <a:round/>
-                      <a:headEnd type="none" w="med" len="med"/>
-                      <a:tailEnd type="none" w="med" len="med"/>
-                    </a:lnR>
-                    <a:lnT w="12700" cap="flat" cmpd="sng" algn="ctr">
-                      <a:solidFill>
-                        <a:schemeClr val="tx1"/>
-                      </a:solidFill>
-                      <a:prstDash val="solid"/>
-                      <a:round/>
-                      <a:headEnd type="none" w="med" len="med"/>
-                      <a:tailEnd type="none" w="med" len="med"/>
-                    </a:lnT>
-                    <a:lnB w="12700" cap="flat" cmpd="sng" algn="ctr">
-                      <a:solidFill>
-                        <a:schemeClr val="tx1"/>
-                      </a:solidFill>
-                      <a:prstDash val="solid"/>
-                      <a:round/>
-                      <a:headEnd type="none" w="med" len="med"/>
-                      <a:tailEnd type="none" w="med" len="med"/>
-                    </a:lnB>
-                    <a:solidFill>
-                      <a:schemeClr val="accent5">
-                        <a:lumMod val="60000"/>
-                        <a:lumOff val="40000"/>
-                      </a:schemeClr>
-                    </a:solidFill>
-                  </a:tcPr>
-                </a:tc>
-                <a:tc>
-                  <a:txBody>
-                    <a:bodyPr/>
-                    <a:lstStyle/>
-                    <a:p>
-                      <a:r>
-                        <a:rPr lang="ru-RU" sz="2000" b="0" kern="0" dirty="0">
-                          <a:solidFill>
-                            <a:srgbClr val="000000"/>
-                          </a:solidFill>
-                          <a:effectLst/>
-                          <a:latin typeface="Times New Roman" panose="02020603050405020304" pitchFamily="18" charset="0"/>
-                        </a:rPr>
-                        <a:t>Блокировки иностранных сервисов в РФ</a:t>
-                      </a:r>
-                      <a:endParaRPr lang="en-US" sz="2000" dirty="0"/>
-                    </a:p>
-                  </a:txBody>
-                  <a:tcPr>
-                    <a:lnL w="12700" cap="flat" cmpd="sng" algn="ctr">
-                      <a:solidFill>
-                        <a:schemeClr val="tx1"/>
-                      </a:solidFill>
-                      <a:prstDash val="solid"/>
-                      <a:round/>
-                      <a:headEnd type="none" w="med" len="med"/>
-                      <a:tailEnd type="none" w="med" len="med"/>
-                    </a:lnL>
-                    <a:lnR w="12700" cap="flat" cmpd="sng" algn="ctr">
-                      <a:solidFill>
-                        <a:schemeClr val="tx1"/>
-                      </a:solidFill>
-                      <a:prstDash val="solid"/>
-                      <a:round/>
-                      <a:headEnd type="none" w="med" len="med"/>
-                      <a:tailEnd type="none" w="med" len="med"/>
-                    </a:lnR>
-                    <a:lnT w="12700" cap="flat" cmpd="sng" algn="ctr">
-                      <a:solidFill>
-                        <a:schemeClr val="tx1"/>
-                      </a:solidFill>
-                      <a:prstDash val="solid"/>
-                      <a:round/>
-                      <a:headEnd type="none" w="med" len="med"/>
-                      <a:tailEnd type="none" w="med" len="med"/>
-                    </a:lnT>
-                    <a:lnB w="12700" cap="flat" cmpd="sng" algn="ctr">
-                      <a:solidFill>
-                        <a:schemeClr val="tx1"/>
-                      </a:solidFill>
-                      <a:prstDash val="solid"/>
-                      <a:round/>
-                      <a:headEnd type="none" w="med" len="med"/>
-                      <a:tailEnd type="none" w="med" len="med"/>
-                    </a:lnB>
-                    <a:solidFill>
-                      <a:schemeClr val="accent5">
-                        <a:lumMod val="60000"/>
-                        <a:lumOff val="40000"/>
-                      </a:schemeClr>
-                    </a:solidFill>
-                  </a:tcPr>
-                </a:tc>
-                <a:extLst>
-                  <a:ext uri="{0D108BD9-81ED-4DB2-BD59-A6C34878D82A}">
-                    <a16:rowId xmlns:a16="http://schemas.microsoft.com/office/drawing/2014/main" val="2791890429"/>
-                  </a:ext>
-                </a:extLst>
-              </a:tr>
-              <a:tr h="696712">
-                <a:tc>
-                  <a:txBody>
-                    <a:bodyPr/>
-                    <a:lstStyle/>
-                    <a:p>
-                      <a:r>
-                        <a:rPr lang="ru-RU" sz="2000" b="0" kern="0" dirty="0">
-                          <a:solidFill>
-                            <a:srgbClr val="000000"/>
-                          </a:solidFill>
-                          <a:effectLst/>
-                          <a:latin typeface="Times New Roman" panose="02020603050405020304" pitchFamily="18" charset="0"/>
-                        </a:rPr>
-                        <a:t>Укрепление Linux на рынке</a:t>
-                      </a:r>
-                      <a:endParaRPr lang="en-US" sz="2000" dirty="0"/>
-                    </a:p>
-                  </a:txBody>
-                  <a:tcPr>
-                    <a:lnL w="12700" cap="flat" cmpd="sng" algn="ctr">
-                      <a:solidFill>
-                        <a:schemeClr val="tx1"/>
-                      </a:solidFill>
-                      <a:prstDash val="solid"/>
-                      <a:round/>
-                      <a:headEnd type="none" w="med" len="med"/>
-                      <a:tailEnd type="none" w="med" len="med"/>
-                    </a:lnL>
-                    <a:lnR w="12700" cap="flat" cmpd="sng" algn="ctr">
-                      <a:solidFill>
-                        <a:schemeClr val="tx1"/>
-                      </a:solidFill>
-                      <a:prstDash val="solid"/>
-                      <a:round/>
-                      <a:headEnd type="none" w="med" len="med"/>
-                      <a:tailEnd type="none" w="med" len="med"/>
-                    </a:lnR>
-                    <a:lnT w="12700" cap="flat" cmpd="sng" algn="ctr">
-                      <a:solidFill>
-                        <a:schemeClr val="tx1"/>
-                      </a:solidFill>
-                      <a:prstDash val="solid"/>
-                      <a:round/>
-                      <a:headEnd type="none" w="med" len="med"/>
-                      <a:tailEnd type="none" w="med" len="med"/>
-                    </a:lnT>
-                    <a:lnB w="12700" cap="flat" cmpd="sng" algn="ctr">
-                      <a:solidFill>
-                        <a:schemeClr val="tx1"/>
-                      </a:solidFill>
-                      <a:prstDash val="solid"/>
-                      <a:round/>
-                      <a:headEnd type="none" w="med" len="med"/>
-                      <a:tailEnd type="none" w="med" len="med"/>
-                    </a:lnB>
-                    <a:solidFill>
-                      <a:schemeClr val="bg1"/>
-                    </a:solidFill>
-                  </a:tcPr>
-                </a:tc>
-                <a:tc>
-                  <a:txBody>
-                    <a:bodyPr/>
-                    <a:lstStyle/>
-                    <a:p>
-                      <a:pPr marL="0" marR="0" lvl="0" indent="0" algn="l" defTabSz="914400" rtl="0" eaLnBrk="1" fontAlgn="auto" latinLnBrk="0" hangingPunct="1">
-                        <a:lnSpc>
-                          <a:spcPct val="100000"/>
-                        </a:lnSpc>
-                        <a:spcBef>
-                          <a:spcPts val="0"/>
-                        </a:spcBef>
-                        <a:spcAft>
-                          <a:spcPts val="0"/>
-                        </a:spcAft>
-                        <a:buClrTx/>
-                        <a:buSzTx/>
-                        <a:buFontTx/>
-                        <a:buNone/>
-                        <a:tabLst/>
-                        <a:defRPr/>
-                      </a:pPr>
-                      <a:r>
-                        <a:rPr lang="ru-RU" sz="2000" b="0" kern="0" dirty="0">
-                          <a:solidFill>
-                            <a:srgbClr val="000000"/>
-                          </a:solidFill>
-                          <a:effectLst/>
-                          <a:latin typeface="Times New Roman" panose="02020603050405020304" pitchFamily="18" charset="0"/>
-                        </a:rPr>
-                        <a:t>Конкурентные аналоги</a:t>
-                      </a:r>
-                      <a:endParaRPr lang="en-US" sz="2000" b="1" kern="0" dirty="0">
-                        <a:solidFill>
-                          <a:srgbClr val="000000"/>
-                        </a:solidFill>
-                        <a:effectLst/>
-                        <a:latin typeface="Times New Roman" panose="02020603050405020304" pitchFamily="18" charset="0"/>
-                      </a:endParaRPr>
-                    </a:p>
-                  </a:txBody>
-                  <a:tcPr>
-                    <a:lnL w="12700" cap="flat" cmpd="sng" algn="ctr">
-                      <a:solidFill>
-                        <a:schemeClr val="tx1"/>
-                      </a:solidFill>
-                      <a:prstDash val="solid"/>
-                      <a:round/>
-                      <a:headEnd type="none" w="med" len="med"/>
-                      <a:tailEnd type="none" w="med" len="med"/>
-                    </a:lnL>
-                    <a:lnR w="12700" cap="flat" cmpd="sng" algn="ctr">
-                      <a:solidFill>
-                        <a:schemeClr val="tx1"/>
-                      </a:solidFill>
-                      <a:prstDash val="solid"/>
-                      <a:round/>
-                      <a:headEnd type="none" w="med" len="med"/>
-                      <a:tailEnd type="none" w="med" len="med"/>
-                    </a:lnR>
-                    <a:lnT w="12700" cap="flat" cmpd="sng" algn="ctr">
-                      <a:solidFill>
-                        <a:schemeClr val="tx1"/>
-                      </a:solidFill>
-                      <a:prstDash val="solid"/>
-                      <a:round/>
-                      <a:headEnd type="none" w="med" len="med"/>
-                      <a:tailEnd type="none" w="med" len="med"/>
-                    </a:lnT>
-                    <a:lnB w="12700" cap="flat" cmpd="sng" algn="ctr">
-                      <a:solidFill>
-                        <a:schemeClr val="tx1"/>
-                      </a:solidFill>
-                      <a:prstDash val="solid"/>
-                      <a:round/>
-                      <a:headEnd type="none" w="med" len="med"/>
-                      <a:tailEnd type="none" w="med" len="med"/>
-                    </a:lnB>
-                    <a:solidFill>
-                      <a:schemeClr val="bg1"/>
-                    </a:solidFill>
-                  </a:tcPr>
-                </a:tc>
-                <a:extLst>
-                  <a:ext uri="{0D108BD9-81ED-4DB2-BD59-A6C34878D82A}">
-                    <a16:rowId xmlns:a16="http://schemas.microsoft.com/office/drawing/2014/main" val="2702449548"/>
-                  </a:ext>
-                </a:extLst>
-              </a:tr>
-              <a:tr h="696712">
-                <a:tc>
-                  <a:txBody>
-                    <a:bodyPr/>
-                    <a:lstStyle/>
-                    <a:p>
-                      <a:r>
-                        <a:rPr lang="ru-RU" sz="2400" b="0" kern="0" dirty="0" err="1">
-                          <a:solidFill>
-                            <a:srgbClr val="000000"/>
-                          </a:solidFill>
-                          <a:effectLst/>
-                          <a:latin typeface="Times New Roman" panose="02020603050405020304" pitchFamily="18" charset="0"/>
-                        </a:rPr>
-                        <a:t>S</a:t>
-                      </a:r>
-                      <a:r>
-                        <a:rPr lang="ru-RU" sz="2400" b="0" kern="0" dirty="0">
-                          <a:solidFill>
-                            <a:srgbClr val="000000"/>
-                          </a:solidFill>
-                          <a:effectLst/>
-                          <a:latin typeface="Times New Roman" panose="02020603050405020304" pitchFamily="18" charset="0"/>
-                        </a:rPr>
-                        <a:t> (сильные стороны)</a:t>
-                      </a:r>
-                      <a:endParaRPr lang="en-US" sz="2400" dirty="0"/>
-                    </a:p>
-                  </a:txBody>
-                  <a:tcPr>
-                    <a:lnL w="12700" cap="flat" cmpd="sng" algn="ctr">
-                      <a:solidFill>
-                        <a:schemeClr val="tx1"/>
-                      </a:solidFill>
-                      <a:prstDash val="solid"/>
-                      <a:round/>
-                      <a:headEnd type="none" w="med" len="med"/>
-                      <a:tailEnd type="none" w="med" len="med"/>
-                    </a:lnL>
-                    <a:lnR w="12700" cap="flat" cmpd="sng" algn="ctr">
-                      <a:solidFill>
-                        <a:schemeClr val="tx1"/>
-                      </a:solidFill>
-                      <a:prstDash val="solid"/>
-                      <a:round/>
-                      <a:headEnd type="none" w="med" len="med"/>
-                      <a:tailEnd type="none" w="med" len="med"/>
-                    </a:lnR>
-                    <a:lnT w="12700" cap="flat" cmpd="sng" algn="ctr">
-                      <a:solidFill>
-                        <a:schemeClr val="tx1"/>
-                      </a:solidFill>
-                      <a:prstDash val="solid"/>
-                      <a:round/>
-                      <a:headEnd type="none" w="med" len="med"/>
-                      <a:tailEnd type="none" w="med" len="med"/>
-                    </a:lnT>
-                    <a:lnB w="12700" cap="flat" cmpd="sng" algn="ctr">
-                      <a:solidFill>
-                        <a:schemeClr val="tx1"/>
-                      </a:solidFill>
-                      <a:prstDash val="solid"/>
-                      <a:round/>
-                      <a:headEnd type="none" w="med" len="med"/>
-                      <a:tailEnd type="none" w="med" len="med"/>
-                    </a:lnB>
-                    <a:solidFill>
-                      <a:schemeClr val="accent1"/>
-                    </a:solidFill>
-                  </a:tcPr>
-                </a:tc>
-                <a:tc>
-                  <a:txBody>
-                    <a:bodyPr/>
-                    <a:lstStyle/>
-                    <a:p>
-                      <a:r>
-                        <a:rPr lang="ru-RU" sz="2400" b="0" kern="0" dirty="0" err="1">
-                          <a:solidFill>
-                            <a:srgbClr val="000000"/>
-                          </a:solidFill>
-                          <a:effectLst/>
-                          <a:latin typeface="Times New Roman" panose="02020603050405020304" pitchFamily="18" charset="0"/>
-                        </a:rPr>
-                        <a:t>W</a:t>
-                      </a:r>
-                      <a:r>
-                        <a:rPr lang="ru-RU" sz="2400" b="0" kern="0" dirty="0">
-                          <a:solidFill>
-                            <a:srgbClr val="000000"/>
-                          </a:solidFill>
-                          <a:effectLst/>
-                          <a:latin typeface="Times New Roman" panose="02020603050405020304" pitchFamily="18" charset="0"/>
-                        </a:rPr>
-                        <a:t> (слабости)</a:t>
-                      </a:r>
-                      <a:endParaRPr lang="en-US" sz="2400" dirty="0"/>
-                    </a:p>
-                  </a:txBody>
-                  <a:tcPr>
-                    <a:lnL w="12700" cap="flat" cmpd="sng" algn="ctr">
-                      <a:solidFill>
-                        <a:schemeClr val="tx1"/>
-                      </a:solidFill>
-                      <a:prstDash val="solid"/>
-                      <a:round/>
-                      <a:headEnd type="none" w="med" len="med"/>
-                      <a:tailEnd type="none" w="med" len="med"/>
-                    </a:lnL>
-                    <a:lnR w="12700" cap="flat" cmpd="sng" algn="ctr">
-                      <a:solidFill>
-                        <a:schemeClr val="tx1"/>
-                      </a:solidFill>
-                      <a:prstDash val="solid"/>
-                      <a:round/>
-                      <a:headEnd type="none" w="med" len="med"/>
-                      <a:tailEnd type="none" w="med" len="med"/>
-                    </a:lnR>
-                    <a:lnT w="12700" cap="flat" cmpd="sng" algn="ctr">
-                      <a:solidFill>
-                        <a:schemeClr val="tx1"/>
-                      </a:solidFill>
-                      <a:prstDash val="solid"/>
-                      <a:round/>
-                      <a:headEnd type="none" w="med" len="med"/>
-                      <a:tailEnd type="none" w="med" len="med"/>
-                    </a:lnT>
-                    <a:lnB w="12700" cap="flat" cmpd="sng" algn="ctr">
-                      <a:solidFill>
-                        <a:schemeClr val="tx1"/>
-                      </a:solidFill>
-                      <a:prstDash val="solid"/>
-                      <a:round/>
-                      <a:headEnd type="none" w="med" len="med"/>
-                      <a:tailEnd type="none" w="med" len="med"/>
-                    </a:lnB>
-                    <a:solidFill>
-                      <a:schemeClr val="accent1"/>
-                    </a:solidFill>
-                  </a:tcPr>
-                </a:tc>
-                <a:extLst>
-                  <a:ext uri="{0D108BD9-81ED-4DB2-BD59-A6C34878D82A}">
-                    <a16:rowId xmlns:a16="http://schemas.microsoft.com/office/drawing/2014/main" val="297882847"/>
-                  </a:ext>
-                </a:extLst>
-              </a:tr>
-              <a:tr h="696712">
-                <a:tc>
-                  <a:txBody>
-                    <a:bodyPr/>
-                    <a:lstStyle/>
-                    <a:p>
-                      <a:pPr marL="0" marR="0" lvl="0" indent="0" algn="l" defTabSz="914400" rtl="0" eaLnBrk="1" fontAlgn="auto" latinLnBrk="0" hangingPunct="1">
-                        <a:lnSpc>
-                          <a:spcPct val="100000"/>
-                        </a:lnSpc>
-                        <a:spcBef>
-                          <a:spcPts val="0"/>
-                        </a:spcBef>
-                        <a:spcAft>
-                          <a:spcPts val="0"/>
-                        </a:spcAft>
-                        <a:buClrTx/>
-                        <a:buSzTx/>
-                        <a:buFontTx/>
-                        <a:buNone/>
-                        <a:tabLst/>
-                        <a:defRPr/>
-                      </a:pPr>
-                      <a:r>
-                        <a:rPr lang="ru-RU" sz="2000" b="0" kern="0" dirty="0">
-                          <a:solidFill>
-                            <a:srgbClr val="000000"/>
-                          </a:solidFill>
-                          <a:effectLst/>
-                          <a:latin typeface="Times New Roman" panose="02020603050405020304" pitchFamily="18" charset="0"/>
-                        </a:rPr>
-                        <a:t>Использование базового </a:t>
-                      </a:r>
-                      <a:r>
-                        <a:rPr lang="ru-RU" sz="2000" b="0" kern="0" dirty="0" err="1">
-                          <a:solidFill>
-                            <a:srgbClr val="000000"/>
-                          </a:solidFill>
-                          <a:effectLst/>
-                          <a:latin typeface="Times New Roman" panose="02020603050405020304" pitchFamily="18" charset="0"/>
-                        </a:rPr>
-                        <a:t>C</a:t>
-                      </a:r>
-                      <a:endParaRPr lang="en-US" sz="2000" dirty="0"/>
-                    </a:p>
-                  </a:txBody>
-                  <a:tcPr>
-                    <a:lnL w="12700" cap="flat" cmpd="sng" algn="ctr">
-                      <a:solidFill>
-                        <a:schemeClr val="tx1"/>
-                      </a:solidFill>
-                      <a:prstDash val="solid"/>
-                      <a:round/>
-                      <a:headEnd type="none" w="med" len="med"/>
-                      <a:tailEnd type="none" w="med" len="med"/>
-                    </a:lnL>
-                    <a:lnR w="12700" cap="flat" cmpd="sng" algn="ctr">
-                      <a:solidFill>
-                        <a:schemeClr val="tx1"/>
-                      </a:solidFill>
-                      <a:prstDash val="solid"/>
-                      <a:round/>
-                      <a:headEnd type="none" w="med" len="med"/>
-                      <a:tailEnd type="none" w="med" len="med"/>
-                    </a:lnR>
-                    <a:lnT w="12700" cap="flat" cmpd="sng" algn="ctr">
-                      <a:solidFill>
-                        <a:schemeClr val="tx1"/>
-                      </a:solidFill>
-                      <a:prstDash val="solid"/>
-                      <a:round/>
-                      <a:headEnd type="none" w="med" len="med"/>
-                      <a:tailEnd type="none" w="med" len="med"/>
-                    </a:lnT>
-                    <a:lnB w="12700" cap="flat" cmpd="sng" algn="ctr">
-                      <a:solidFill>
-                        <a:schemeClr val="tx1"/>
-                      </a:solidFill>
-                      <a:prstDash val="solid"/>
-                      <a:round/>
-                      <a:headEnd type="none" w="med" len="med"/>
-                      <a:tailEnd type="none" w="med" len="med"/>
-                    </a:lnB>
-                    <a:solidFill>
-                      <a:schemeClr val="bg1"/>
-                    </a:solidFill>
-                  </a:tcPr>
-                </a:tc>
-                <a:tc>
-                  <a:txBody>
-                    <a:bodyPr/>
-                    <a:lstStyle/>
-                    <a:p>
-                      <a:r>
-                        <a:rPr lang="ru-RU" sz="2000" b="0" kern="0" dirty="0">
-                          <a:solidFill>
-                            <a:srgbClr val="000000"/>
-                          </a:solidFill>
-                          <a:effectLst/>
-                          <a:latin typeface="Times New Roman" panose="02020603050405020304" pitchFamily="18" charset="0"/>
-                        </a:rPr>
-                        <a:t>Недостаточное тестирование</a:t>
-                      </a:r>
-                      <a:endParaRPr lang="en-US" sz="2000" dirty="0"/>
-                    </a:p>
-                  </a:txBody>
-                  <a:tcPr>
-                    <a:lnL w="12700" cap="flat" cmpd="sng" algn="ctr">
-                      <a:solidFill>
-                        <a:schemeClr val="tx1"/>
-                      </a:solidFill>
-                      <a:prstDash val="solid"/>
-                      <a:round/>
-                      <a:headEnd type="none" w="med" len="med"/>
-                      <a:tailEnd type="none" w="med" len="med"/>
-                    </a:lnL>
-                    <a:lnR w="12700" cap="flat" cmpd="sng" algn="ctr">
-                      <a:solidFill>
-                        <a:schemeClr val="tx1"/>
-                      </a:solidFill>
-                      <a:prstDash val="solid"/>
-                      <a:round/>
-                      <a:headEnd type="none" w="med" len="med"/>
-                      <a:tailEnd type="none" w="med" len="med"/>
-                    </a:lnR>
-                    <a:lnT w="12700" cap="flat" cmpd="sng" algn="ctr">
-                      <a:solidFill>
-                        <a:schemeClr val="tx1"/>
-                      </a:solidFill>
-                      <a:prstDash val="solid"/>
-                      <a:round/>
-                      <a:headEnd type="none" w="med" len="med"/>
-                      <a:tailEnd type="none" w="med" len="med"/>
-                    </a:lnT>
-                    <a:lnB w="12700" cap="flat" cmpd="sng" algn="ctr">
-                      <a:solidFill>
-                        <a:schemeClr val="tx1"/>
-                      </a:solidFill>
-                      <a:prstDash val="solid"/>
-                      <a:round/>
-                      <a:headEnd type="none" w="med" len="med"/>
-                      <a:tailEnd type="none" w="med" len="med"/>
-                    </a:lnB>
-                    <a:solidFill>
-                      <a:schemeClr val="bg1"/>
-                    </a:solidFill>
-                  </a:tcPr>
-                </a:tc>
-                <a:extLst>
-                  <a:ext uri="{0D108BD9-81ED-4DB2-BD59-A6C34878D82A}">
-                    <a16:rowId xmlns:a16="http://schemas.microsoft.com/office/drawing/2014/main" val="39607990"/>
-                  </a:ext>
-                </a:extLst>
-              </a:tr>
-              <a:tr h="696712">
-                <a:tc>
-                  <a:txBody>
-                    <a:bodyPr/>
-                    <a:lstStyle/>
-                    <a:p>
-                      <a:r>
-                        <a:rPr lang="ru-RU" sz="2000" b="0" kern="0" dirty="0">
-                          <a:solidFill>
-                            <a:srgbClr val="000000"/>
-                          </a:solidFill>
-                          <a:effectLst/>
-                          <a:latin typeface="Times New Roman" panose="02020603050405020304" pitchFamily="18" charset="0"/>
-                        </a:rPr>
-                        <a:t>Совмещение функционала программ</a:t>
-                      </a:r>
-                      <a:endParaRPr lang="en-US" sz="2000" dirty="0"/>
-                    </a:p>
-                  </a:txBody>
-                  <a:tcPr>
-                    <a:lnL w="12700" cap="flat" cmpd="sng" algn="ctr">
-                      <a:solidFill>
-                        <a:schemeClr val="tx1"/>
-                      </a:solidFill>
-                      <a:prstDash val="solid"/>
-                      <a:round/>
-                      <a:headEnd type="none" w="med" len="med"/>
-                      <a:tailEnd type="none" w="med" len="med"/>
-                    </a:lnL>
-                    <a:lnR w="12700" cap="flat" cmpd="sng" algn="ctr">
-                      <a:solidFill>
-                        <a:schemeClr val="tx1"/>
-                      </a:solidFill>
-                      <a:prstDash val="solid"/>
-                      <a:round/>
-                      <a:headEnd type="none" w="med" len="med"/>
-                      <a:tailEnd type="none" w="med" len="med"/>
-                    </a:lnR>
-                    <a:lnT w="12700" cap="flat" cmpd="sng" algn="ctr">
-                      <a:solidFill>
-                        <a:schemeClr val="tx1"/>
-                      </a:solidFill>
-                      <a:prstDash val="solid"/>
-                      <a:round/>
-                      <a:headEnd type="none" w="med" len="med"/>
-                      <a:tailEnd type="none" w="med" len="med"/>
-                    </a:lnT>
-                    <a:lnB w="12700" cap="flat" cmpd="sng" algn="ctr">
-                      <a:solidFill>
-                        <a:schemeClr val="tx1"/>
-                      </a:solidFill>
-                      <a:prstDash val="solid"/>
-                      <a:round/>
-                      <a:headEnd type="none" w="med" len="med"/>
-                      <a:tailEnd type="none" w="med" len="med"/>
-                    </a:lnB>
-                    <a:solidFill>
-                      <a:schemeClr val="accent5">
-                        <a:lumMod val="60000"/>
-                        <a:lumOff val="40000"/>
-                      </a:schemeClr>
-                    </a:solidFill>
-                  </a:tcPr>
-                </a:tc>
-                <a:tc>
-                  <a:txBody>
-                    <a:bodyPr/>
-                    <a:lstStyle/>
-                    <a:p>
-                      <a:r>
-                        <a:rPr lang="ru-RU" sz="2000" b="0" kern="0" dirty="0">
-                          <a:solidFill>
-                            <a:srgbClr val="000000"/>
-                          </a:solidFill>
-                          <a:effectLst/>
-                          <a:latin typeface="Times New Roman" panose="02020603050405020304" pitchFamily="18" charset="0"/>
-                        </a:rPr>
-                        <a:t>Ограниченность функционала</a:t>
-                      </a:r>
-                      <a:endParaRPr lang="en-US" sz="2000" dirty="0"/>
-                    </a:p>
-                  </a:txBody>
-                  <a:tcPr>
-                    <a:lnL w="12700" cap="flat" cmpd="sng" algn="ctr">
-                      <a:solidFill>
-                        <a:schemeClr val="tx1"/>
-                      </a:solidFill>
-                      <a:prstDash val="solid"/>
-                      <a:round/>
-                      <a:headEnd type="none" w="med" len="med"/>
-                      <a:tailEnd type="none" w="med" len="med"/>
-                    </a:lnL>
-                    <a:lnR w="12700" cap="flat" cmpd="sng" algn="ctr">
-                      <a:solidFill>
-                        <a:schemeClr val="tx1"/>
-                      </a:solidFill>
-                      <a:prstDash val="solid"/>
-                      <a:round/>
-                      <a:headEnd type="none" w="med" len="med"/>
-                      <a:tailEnd type="none" w="med" len="med"/>
-                    </a:lnR>
-                    <a:lnT w="12700" cap="flat" cmpd="sng" algn="ctr">
-                      <a:solidFill>
-                        <a:schemeClr val="tx1"/>
-                      </a:solidFill>
-                      <a:prstDash val="solid"/>
-                      <a:round/>
-                      <a:headEnd type="none" w="med" len="med"/>
-                      <a:tailEnd type="none" w="med" len="med"/>
-                    </a:lnT>
-                    <a:lnB w="12700" cap="flat" cmpd="sng" algn="ctr">
-                      <a:solidFill>
-                        <a:schemeClr val="tx1"/>
-                      </a:solidFill>
-                      <a:prstDash val="solid"/>
-                      <a:round/>
-                      <a:headEnd type="none" w="med" len="med"/>
-                      <a:tailEnd type="none" w="med" len="med"/>
-                    </a:lnB>
-                    <a:solidFill>
-                      <a:schemeClr val="accent5">
-                        <a:lumMod val="60000"/>
-                        <a:lumOff val="40000"/>
-                      </a:schemeClr>
-                    </a:solidFill>
-                  </a:tcPr>
-                </a:tc>
-                <a:extLst>
-                  <a:ext uri="{0D108BD9-81ED-4DB2-BD59-A6C34878D82A}">
-                    <a16:rowId xmlns:a16="http://schemas.microsoft.com/office/drawing/2014/main" val="4119764893"/>
-                  </a:ext>
-                </a:extLst>
-              </a:tr>
-              <a:tr h="696712">
-                <a:tc>
-                  <a:txBody>
-                    <a:bodyPr/>
-                    <a:lstStyle/>
-                    <a:p>
-                      <a:pPr marL="0" marR="0" lvl="0" indent="0" algn="l" defTabSz="914400" rtl="0" eaLnBrk="1" fontAlgn="auto" latinLnBrk="0" hangingPunct="1">
-                        <a:lnSpc>
-                          <a:spcPct val="100000"/>
-                        </a:lnSpc>
-                        <a:spcBef>
-                          <a:spcPts val="0"/>
-                        </a:spcBef>
-                        <a:spcAft>
-                          <a:spcPts val="0"/>
-                        </a:spcAft>
-                        <a:buClrTx/>
-                        <a:buSzTx/>
-                        <a:buFontTx/>
-                        <a:buNone/>
-                        <a:tabLst/>
-                        <a:defRPr/>
-                      </a:pPr>
-                      <a:r>
-                        <a:rPr lang="ru-RU" sz="2000" b="0" kern="0" dirty="0" err="1">
-                          <a:solidFill>
-                            <a:srgbClr val="000000"/>
-                          </a:solidFill>
-                          <a:effectLst/>
-                          <a:latin typeface="Times New Roman" panose="02020603050405020304" pitchFamily="18" charset="0"/>
-                        </a:rPr>
-                        <a:t>Портируемость</a:t>
-                      </a:r>
-                      <a:endParaRPr lang="en-US" sz="2000" b="1" kern="0" dirty="0">
-                        <a:solidFill>
-                          <a:srgbClr val="000000"/>
-                        </a:solidFill>
-                        <a:effectLst/>
-                        <a:latin typeface="Times New Roman" panose="02020603050405020304" pitchFamily="18" charset="0"/>
-                      </a:endParaRPr>
-                    </a:p>
-                  </a:txBody>
-                  <a:tcPr>
-                    <a:lnL w="12700" cap="flat" cmpd="sng" algn="ctr">
-                      <a:solidFill>
-                        <a:schemeClr val="tx1"/>
-                      </a:solidFill>
-                      <a:prstDash val="solid"/>
-                      <a:round/>
-                      <a:headEnd type="none" w="med" len="med"/>
-                      <a:tailEnd type="none" w="med" len="med"/>
-                    </a:lnL>
-                    <a:lnR w="12700" cap="flat" cmpd="sng" algn="ctr">
-                      <a:solidFill>
-                        <a:schemeClr val="tx1"/>
-                      </a:solidFill>
-                      <a:prstDash val="solid"/>
-                      <a:round/>
-                      <a:headEnd type="none" w="med" len="med"/>
-                      <a:tailEnd type="none" w="med" len="med"/>
-                    </a:lnR>
-                    <a:lnT w="12700" cap="flat" cmpd="sng" algn="ctr">
-                      <a:solidFill>
-                        <a:schemeClr val="tx1"/>
-                      </a:solidFill>
-                      <a:prstDash val="solid"/>
-                      <a:round/>
-                      <a:headEnd type="none" w="med" len="med"/>
-                      <a:tailEnd type="none" w="med" len="med"/>
-                    </a:lnT>
-                    <a:lnB w="12700" cap="flat" cmpd="sng" algn="ctr">
-                      <a:solidFill>
-                        <a:schemeClr val="tx1"/>
-                      </a:solidFill>
-                      <a:prstDash val="solid"/>
-                      <a:round/>
-                      <a:headEnd type="none" w="med" len="med"/>
-                      <a:tailEnd type="none" w="med" len="med"/>
-                    </a:lnB>
-                    <a:solidFill>
-                      <a:schemeClr val="bg1"/>
-                    </a:solidFill>
-                  </a:tcPr>
-                </a:tc>
-                <a:tc>
-                  <a:txBody>
-                    <a:bodyPr/>
-                    <a:lstStyle/>
-                    <a:p>
-                      <a:r>
-                        <a:rPr lang="ru-RU" sz="2000" b="0" kern="0" dirty="0">
-                          <a:solidFill>
-                            <a:srgbClr val="000000"/>
-                          </a:solidFill>
-                          <a:effectLst/>
-                          <a:latin typeface="Times New Roman" panose="02020603050405020304" pitchFamily="18" charset="0"/>
-                        </a:rPr>
-                        <a:t>Требует работы в терминале</a:t>
-                      </a:r>
-                      <a:endParaRPr lang="en-US" sz="2000" dirty="0"/>
-                    </a:p>
-                  </a:txBody>
-                  <a:tcPr>
-                    <a:lnL w="12700" cap="flat" cmpd="sng" algn="ctr">
-                      <a:solidFill>
-                        <a:schemeClr val="tx1"/>
-                      </a:solidFill>
-                      <a:prstDash val="solid"/>
-                      <a:round/>
-                      <a:headEnd type="none" w="med" len="med"/>
-                      <a:tailEnd type="none" w="med" len="med"/>
-                    </a:lnL>
-                    <a:lnR w="12700" cap="flat" cmpd="sng" algn="ctr">
-                      <a:solidFill>
-                        <a:schemeClr val="tx1"/>
-                      </a:solidFill>
-                      <a:prstDash val="solid"/>
-                      <a:round/>
-                      <a:headEnd type="none" w="med" len="med"/>
-                      <a:tailEnd type="none" w="med" len="med"/>
-                    </a:lnR>
-                    <a:lnT w="12700" cap="flat" cmpd="sng" algn="ctr">
-                      <a:solidFill>
-                        <a:schemeClr val="tx1"/>
-                      </a:solidFill>
-                      <a:prstDash val="solid"/>
-                      <a:round/>
-                      <a:headEnd type="none" w="med" len="med"/>
-                      <a:tailEnd type="none" w="med" len="med"/>
-                    </a:lnT>
-                    <a:lnB w="12700" cap="flat" cmpd="sng" algn="ctr">
-                      <a:solidFill>
-                        <a:schemeClr val="tx1"/>
-                      </a:solidFill>
-                      <a:prstDash val="solid"/>
-                      <a:round/>
-                      <a:headEnd type="none" w="med" len="med"/>
-                      <a:tailEnd type="none" w="med" len="med"/>
-                    </a:lnB>
-                    <a:solidFill>
-                      <a:schemeClr val="bg1"/>
-                    </a:solidFill>
-                  </a:tcPr>
-                </a:tc>
-                <a:extLst>
-                  <a:ext uri="{0D108BD9-81ED-4DB2-BD59-A6C34878D82A}">
-                    <a16:rowId xmlns:a16="http://schemas.microsoft.com/office/drawing/2014/main" val="697641321"/>
-                  </a:ext>
-                </a:extLst>
-              </a:tr>
-            </a:tbl>
-          </a:graphicData>
-        </a:graphic>
-      </p:graphicFrame>
+      <p:sp>
+        <p:nvSpPr>
+          <p:cNvPr id="3" name="TextBox 2">
+            <a:extLst>
+              <a:ext uri="{FF2B5EF4-FFF2-40B4-BE49-F238E27FC236}">
+                <a16:creationId xmlns:a16="http://schemas.microsoft.com/office/drawing/2014/main" id="{99A942A6-8CB4-7B23-2DDE-C1535920952E}"/>
+              </a:ext>
+            </a:extLst>
+          </p:cNvPr>
+          <p:cNvSpPr txBox="1"/>
+          <p:nvPr/>
+        </p:nvSpPr>
+        <p:spPr>
+          <a:xfrm>
+            <a:off x="1637068" y="668594"/>
+            <a:ext cx="8917859" cy="2462213"/>
+          </a:xfrm>
+          <a:prstGeom prst="rect">
+            <a:avLst/>
+          </a:prstGeom>
+          <a:noFill/>
+        </p:spPr>
+        <p:txBody>
+          <a:bodyPr wrap="square" rtlCol="0">
+            <a:spAutoFit/>
+          </a:bodyPr>
+          <a:lstStyle/>
+          <a:p>
+            <a:r>
+              <a:rPr lang="ru-RU" sz="2200" dirty="0"/>
+              <a:t>Наша программа (</a:t>
+            </a:r>
+            <a:r>
+              <a:rPr lang="en-US" sz="2200" dirty="0" err="1"/>
+              <a:t>pdd</a:t>
+            </a:r>
+            <a:r>
+              <a:rPr lang="en-US" sz="2200" dirty="0"/>
+              <a:t> – professional disk diagnostic</a:t>
+            </a:r>
+            <a:r>
+              <a:rPr lang="ru-RU" sz="2200" dirty="0"/>
+              <a:t>)</a:t>
+            </a:r>
+            <a:r>
+              <a:rPr lang="en-US" sz="2200" dirty="0"/>
+              <a:t> </a:t>
+            </a:r>
+            <a:r>
+              <a:rPr lang="ru-RU" sz="2200" dirty="0"/>
+              <a:t>предназначена для глубокой диагностики накопителей (</a:t>
+            </a:r>
+            <a:r>
+              <a:rPr lang="en-US" sz="2200" dirty="0"/>
+              <a:t>HDD, SSD, NVME, Flash</a:t>
+            </a:r>
+            <a:r>
+              <a:rPr lang="ru-RU" sz="2200" dirty="0"/>
+              <a:t>)</a:t>
+            </a:r>
+            <a:r>
+              <a:rPr lang="en-US" sz="2200" dirty="0"/>
+              <a:t>. </a:t>
+            </a:r>
+            <a:r>
+              <a:rPr lang="ru-RU" sz="2200" dirty="0"/>
+              <a:t>Она может вывести подробную информацию о дисковой подсистеме (конфигурация, температура, ошибки ввода/вывода), замерить скорость чтения/записи, провести проверку на битые сектора, проанализировать использование места на диске, отформатировать его. Работает из терминала и устанавливается одной командой.</a:t>
+            </a:r>
+            <a:endParaRPr lang="en-US" sz="2200" dirty="0"/>
+          </a:p>
+        </p:txBody>
+      </p:sp>
+      <p:sp>
+        <p:nvSpPr>
+          <p:cNvPr id="4" name="TextBox 3">
+            <a:extLst>
+              <a:ext uri="{FF2B5EF4-FFF2-40B4-BE49-F238E27FC236}">
+                <a16:creationId xmlns:a16="http://schemas.microsoft.com/office/drawing/2014/main" id="{74A15736-758F-5A3F-9C4B-6DCB10CD5F0F}"/>
+              </a:ext>
+            </a:extLst>
+          </p:cNvPr>
+          <p:cNvSpPr txBox="1"/>
+          <p:nvPr/>
+        </p:nvSpPr>
+        <p:spPr>
+          <a:xfrm>
+            <a:off x="1637067" y="3727194"/>
+            <a:ext cx="8917859" cy="769441"/>
+          </a:xfrm>
+          <a:prstGeom prst="rect">
+            <a:avLst/>
+          </a:prstGeom>
+          <a:noFill/>
+        </p:spPr>
+        <p:txBody>
+          <a:bodyPr wrap="square" rtlCol="0">
+            <a:spAutoFit/>
+          </a:bodyPr>
+          <a:lstStyle/>
+          <a:p>
+            <a:r>
+              <a:rPr lang="ru-RU" sz="2200" dirty="0"/>
+              <a:t>Ожидаемая аудитория: системные администраторы ПК с </a:t>
+            </a:r>
+            <a:r>
+              <a:rPr lang="en-US" sz="2200" dirty="0"/>
+              <a:t>Linux, </a:t>
+            </a:r>
+            <a:r>
+              <a:rPr lang="ru-RU" sz="2200" dirty="0"/>
+              <a:t>пользователи </a:t>
+            </a:r>
+            <a:r>
+              <a:rPr lang="en-US" sz="2200" dirty="0"/>
+              <a:t>UNIX-</a:t>
+            </a:r>
+            <a:r>
+              <a:rPr lang="ru-RU" sz="2200" dirty="0"/>
+              <a:t>подобных ОС</a:t>
+            </a:r>
+            <a:endParaRPr lang="en-US" sz="2200" dirty="0"/>
+          </a:p>
+        </p:txBody>
+      </p:sp>
+      <p:pic>
+        <p:nvPicPr>
+          <p:cNvPr id="1026" name="Picture 2" descr="Почему linux должен быть единственной системой в образовательном процессе /  Хабр">
+            <a:extLst>
+              <a:ext uri="{FF2B5EF4-FFF2-40B4-BE49-F238E27FC236}">
+                <a16:creationId xmlns:a16="http://schemas.microsoft.com/office/drawing/2014/main" id="{BD5A62D2-676F-15C0-B4B3-8FAFA5B12D5C}"/>
+              </a:ext>
+            </a:extLst>
+          </p:cNvPr>
+          <p:cNvPicPr>
+            <a:picLocks noChangeAspect="1" noChangeArrowheads="1"/>
+          </p:cNvPicPr>
+          <p:nvPr/>
+        </p:nvPicPr>
+        <p:blipFill>
+          <a:blip r:embed="rId2">
+            <a:extLst>
+              <a:ext uri="{28A0092B-C50C-407E-A947-70E740481C1C}">
+                <a14:useLocalDpi xmlns:a14="http://schemas.microsoft.com/office/drawing/2010/main" val="0"/>
+              </a:ext>
+            </a:extLst>
+          </a:blip>
+          <a:srcRect/>
+          <a:stretch>
+            <a:fillRect/>
+          </a:stretch>
+        </p:blipFill>
+        <p:spPr bwMode="auto">
+          <a:xfrm>
+            <a:off x="3957404" y="4496635"/>
+            <a:ext cx="4277191" cy="2361365"/>
+          </a:xfrm>
+          <a:prstGeom prst="rect">
+            <a:avLst/>
+          </a:prstGeom>
+          <a:noFill/>
+          <a:extLst>
+            <a:ext uri="{909E8E84-426E-40DD-AFC4-6F175D3DCCD1}">
+              <a14:hiddenFill xmlns:a14="http://schemas.microsoft.com/office/drawing/2010/main">
+                <a:solidFill>
+                  <a:srgbClr val="FFFFFF"/>
+                </a:solidFill>
+              </a14:hiddenFill>
+            </a:ext>
+          </a:extLst>
+        </p:spPr>
+      </p:pic>
     </p:spTree>
     <p:extLst>
       <p:ext uri="{BB962C8B-B14F-4D97-AF65-F5344CB8AC3E}">
-        <p14:creationId xmlns:p14="http://schemas.microsoft.com/office/powerpoint/2010/main" val="891120530"/>
+        <p14:creationId xmlns:p14="http://schemas.microsoft.com/office/powerpoint/2010/main" val="4052126513"/>
       </p:ext>
     </p:extLst>
   </p:cSld>
@@ -6443,119 +4426,7 @@
 </p:sld>
 </file>
 
-<file path=ppt/slides/slide8.xml><?xml version="1.0" encoding="utf-8"?>
-<p:sld xmlns:a="http://schemas.openxmlformats.org/drawingml/2006/main" xmlns:r="http://schemas.openxmlformats.org/officeDocument/2006/relationships" xmlns:p="http://schemas.openxmlformats.org/presentationml/2006/main">
-  <p:cSld>
-    <p:spTree>
-      <p:nvGrpSpPr>
-        <p:cNvPr id="1" name=""/>
-        <p:cNvGrpSpPr/>
-        <p:nvPr/>
-      </p:nvGrpSpPr>
-      <p:grpSpPr>
-        <a:xfrm>
-          <a:off x="0" y="0"/>
-          <a:ext cx="0" cy="0"/>
-          <a:chOff x="0" y="0"/>
-          <a:chExt cx="0" cy="0"/>
-        </a:xfrm>
-      </p:grpSpPr>
-      <p:sp>
-        <p:nvSpPr>
-          <p:cNvPr id="2" name="Заголовок 1">
-            <a:extLst>
-              <a:ext uri="{FF2B5EF4-FFF2-40B4-BE49-F238E27FC236}">
-                <a16:creationId xmlns:a16="http://schemas.microsoft.com/office/drawing/2014/main" id="{7D943821-AECF-4A55-8E12-49D7F394EDD7}"/>
-              </a:ext>
-            </a:extLst>
-          </p:cNvPr>
-          <p:cNvSpPr>
-            <a:spLocks noGrp="1"/>
-          </p:cNvSpPr>
-          <p:nvPr>
-            <p:ph type="title"/>
-          </p:nvPr>
-        </p:nvSpPr>
-        <p:spPr>
-          <a:xfrm>
-            <a:off x="4813852" y="0"/>
-            <a:ext cx="2564296" cy="1325563"/>
-          </a:xfrm>
-        </p:spPr>
-        <p:txBody>
-          <a:bodyPr>
-            <a:normAutofit/>
-          </a:bodyPr>
-          <a:lstStyle/>
-          <a:p>
-            <a:r>
-              <a:rPr lang="ru-RU" sz="3200" dirty="0"/>
-              <a:t>График </a:t>
-            </a:r>
-            <a:r>
-              <a:rPr lang="ru-RU" sz="3200" dirty="0" err="1"/>
-              <a:t>Ганта</a:t>
-            </a:r>
-            <a:endParaRPr lang="ru-RU" sz="3200" dirty="0"/>
-          </a:p>
-        </p:txBody>
-      </p:sp>
-      <p:pic>
-        <p:nvPicPr>
-          <p:cNvPr id="8" name="Рисунок 7">
-            <a:extLst>
-              <a:ext uri="{FF2B5EF4-FFF2-40B4-BE49-F238E27FC236}">
-                <a16:creationId xmlns:a16="http://schemas.microsoft.com/office/drawing/2014/main" id="{D147E087-4B5C-4092-AEAD-DF84798A62BD}"/>
-              </a:ext>
-            </a:extLst>
-          </p:cNvPr>
-          <p:cNvPicPr>
-            <a:picLocks noChangeAspect="1"/>
-          </p:cNvPicPr>
-          <p:nvPr/>
-        </p:nvPicPr>
-        <p:blipFill>
-          <a:blip r:embed="rId2"/>
-          <a:stretch>
-            <a:fillRect/>
-          </a:stretch>
-        </p:blipFill>
-        <p:spPr>
-          <a:xfrm>
-            <a:off x="0" y="2223224"/>
-            <a:ext cx="12205293" cy="2411551"/>
-          </a:xfrm>
-          <a:prstGeom prst="rect">
-            <a:avLst/>
-          </a:prstGeom>
-        </p:spPr>
-      </p:pic>
-    </p:spTree>
-    <p:extLst>
-      <p:ext uri="{BB962C8B-B14F-4D97-AF65-F5344CB8AC3E}">
-        <p14:creationId xmlns:p14="http://schemas.microsoft.com/office/powerpoint/2010/main" val="2515464613"/>
-      </p:ext>
-    </p:extLst>
-  </p:cSld>
-  <p:clrMapOvr>
-    <a:masterClrMapping/>
-  </p:clrMapOvr>
-  <mc:AlternateContent xmlns:mc="http://schemas.openxmlformats.org/markup-compatibility/2006" xmlns:p159="http://schemas.microsoft.com/office/powerpoint/2015/09/main">
-    <mc:Choice Requires="p159">
-      <p:transition xmlns:p14="http://schemas.microsoft.com/office/powerpoint/2010/main" spd="slow" p14:dur="2000">
-        <p159:morph option="byObject"/>
-      </p:transition>
-    </mc:Choice>
-    <mc:Fallback xmlns="">
-      <p:transition spd="slow">
-        <p:fade/>
-      </p:transition>
-    </mc:Fallback>
-  </mc:AlternateContent>
-</p:sld>
-</file>
-
-<file path=ppt/slides/slide9.xml><?xml version="1.0" encoding="utf-8"?>
+<file path=ppt/slides/slide6.xml><?xml version="1.0" encoding="utf-8"?>
 <p:sld xmlns:a="http://schemas.openxmlformats.org/drawingml/2006/main" xmlns:r="http://schemas.openxmlformats.org/officeDocument/2006/relationships" xmlns:p="http://schemas.openxmlformats.org/presentationml/2006/main">
   <p:cSld>
     <p:spTree>
@@ -8428,6 +6299,473 @@
     <p:extLst>
       <p:ext uri="{BB962C8B-B14F-4D97-AF65-F5344CB8AC3E}">
         <p14:creationId xmlns:p14="http://schemas.microsoft.com/office/powerpoint/2010/main" val="2016983813"/>
+      </p:ext>
+    </p:extLst>
+  </p:cSld>
+  <p:clrMapOvr>
+    <a:masterClrMapping/>
+  </p:clrMapOvr>
+  <mc:AlternateContent xmlns:mc="http://schemas.openxmlformats.org/markup-compatibility/2006" xmlns:p159="http://schemas.microsoft.com/office/powerpoint/2015/09/main">
+    <mc:Choice Requires="p159">
+      <p:transition xmlns:p14="http://schemas.microsoft.com/office/powerpoint/2010/main" spd="slow" p14:dur="2000">
+        <p159:morph option="byObject"/>
+      </p:transition>
+    </mc:Choice>
+    <mc:Fallback xmlns="">
+      <p:transition spd="slow">
+        <p:fade/>
+      </p:transition>
+    </mc:Fallback>
+  </mc:AlternateContent>
+</p:sld>
+</file>
+
+<file path=ppt/slides/slide7.xml><?xml version="1.0" encoding="utf-8"?>
+<p:sld xmlns:a="http://schemas.openxmlformats.org/drawingml/2006/main" xmlns:r="http://schemas.openxmlformats.org/officeDocument/2006/relationships" xmlns:p="http://schemas.openxmlformats.org/presentationml/2006/main">
+  <p:cSld>
+    <p:spTree>
+      <p:nvGrpSpPr>
+        <p:cNvPr id="1" name=""/>
+        <p:cNvGrpSpPr/>
+        <p:nvPr/>
+      </p:nvGrpSpPr>
+      <p:grpSpPr>
+        <a:xfrm>
+          <a:off x="0" y="0"/>
+          <a:ext cx="0" cy="0"/>
+          <a:chOff x="0" y="0"/>
+          <a:chExt cx="0" cy="0"/>
+        </a:xfrm>
+      </p:grpSpPr>
+      <p:sp>
+        <p:nvSpPr>
+          <p:cNvPr id="2" name="Заголовок 1">
+            <a:extLst>
+              <a:ext uri="{FF2B5EF4-FFF2-40B4-BE49-F238E27FC236}">
+                <a16:creationId xmlns:a16="http://schemas.microsoft.com/office/drawing/2014/main" id="{7D943821-AECF-4A55-8E12-49D7F394EDD7}"/>
+              </a:ext>
+            </a:extLst>
+          </p:cNvPr>
+          <p:cNvSpPr>
+            <a:spLocks noGrp="1"/>
+          </p:cNvSpPr>
+          <p:nvPr>
+            <p:ph type="title"/>
+          </p:nvPr>
+        </p:nvSpPr>
+        <p:spPr>
+          <a:xfrm>
+            <a:off x="3533358" y="238540"/>
+            <a:ext cx="5125279" cy="764999"/>
+          </a:xfrm>
+        </p:spPr>
+        <p:txBody>
+          <a:bodyPr>
+            <a:normAutofit/>
+          </a:bodyPr>
+          <a:lstStyle/>
+          <a:p>
+            <a:r>
+              <a:rPr lang="ru-RU" sz="4000" dirty="0"/>
+              <a:t>Дальнейшее  развитие</a:t>
+            </a:r>
+          </a:p>
+        </p:txBody>
+      </p:sp>
+      <p:pic>
+        <p:nvPicPr>
+          <p:cNvPr id="2050" name="Picture 2" descr="Развитие">
+            <a:extLst>
+              <a:ext uri="{FF2B5EF4-FFF2-40B4-BE49-F238E27FC236}">
+                <a16:creationId xmlns:a16="http://schemas.microsoft.com/office/drawing/2014/main" id="{FDC0DFEF-B865-A3A4-4B8C-50327729B1C4}"/>
+              </a:ext>
+            </a:extLst>
+          </p:cNvPr>
+          <p:cNvPicPr>
+            <a:picLocks noChangeAspect="1" noChangeArrowheads="1"/>
+          </p:cNvPicPr>
+          <p:nvPr/>
+        </p:nvPicPr>
+        <p:blipFill>
+          <a:blip r:embed="rId2">
+            <a:extLst>
+              <a:ext uri="{28A0092B-C50C-407E-A947-70E740481C1C}">
+                <a14:useLocalDpi xmlns:a14="http://schemas.microsoft.com/office/drawing/2010/main" val="0"/>
+              </a:ext>
+            </a:extLst>
+          </a:blip>
+          <a:srcRect/>
+          <a:stretch>
+            <a:fillRect/>
+          </a:stretch>
+        </p:blipFill>
+        <p:spPr bwMode="auto">
+          <a:xfrm>
+            <a:off x="9742004" y="4154557"/>
+            <a:ext cx="2449995" cy="2703443"/>
+          </a:xfrm>
+          <a:prstGeom prst="rect">
+            <a:avLst/>
+          </a:prstGeom>
+          <a:noFill/>
+          <a:extLst>
+            <a:ext uri="{909E8E84-426E-40DD-AFC4-6F175D3DCCD1}">
+              <a14:hiddenFill xmlns:a14="http://schemas.microsoft.com/office/drawing/2010/main">
+                <a:solidFill>
+                  <a:srgbClr val="FFFFFF"/>
+                </a:solidFill>
+              </a14:hiddenFill>
+            </a:ext>
+          </a:extLst>
+        </p:spPr>
+      </p:pic>
+      <p:sp>
+        <p:nvSpPr>
+          <p:cNvPr id="3" name="TextBox 2">
+            <a:extLst>
+              <a:ext uri="{FF2B5EF4-FFF2-40B4-BE49-F238E27FC236}">
+                <a16:creationId xmlns:a16="http://schemas.microsoft.com/office/drawing/2014/main" id="{717A9FA7-B1B1-62D8-C2C2-58149670A106}"/>
+              </a:ext>
+            </a:extLst>
+          </p:cNvPr>
+          <p:cNvSpPr txBox="1"/>
+          <p:nvPr/>
+        </p:nvSpPr>
+        <p:spPr>
+          <a:xfrm>
+            <a:off x="1592745" y="1859339"/>
+            <a:ext cx="9006507" cy="2800767"/>
+          </a:xfrm>
+          <a:prstGeom prst="rect">
+            <a:avLst/>
+          </a:prstGeom>
+          <a:noFill/>
+        </p:spPr>
+        <p:txBody>
+          <a:bodyPr wrap="square" rtlCol="0">
+            <a:spAutoFit/>
+          </a:bodyPr>
+          <a:lstStyle/>
+          <a:p>
+            <a:r>
+              <a:rPr lang="en-US" sz="2200" dirty="0"/>
+              <a:t>PDD</a:t>
+            </a:r>
+            <a:r>
+              <a:rPr lang="ru-RU" sz="2200" dirty="0"/>
+              <a:t> будет развиваться постепенно:</a:t>
+            </a:r>
+          </a:p>
+          <a:p>
+            <a:pPr marL="285750" indent="-285750">
+              <a:buFont typeface="Arial" panose="020B0604020202020204" pitchFamily="34" charset="0"/>
+              <a:buChar char="•"/>
+            </a:pPr>
+            <a:r>
+              <a:rPr lang="ru-RU" sz="2200" dirty="0"/>
+              <a:t>Будут добавляться новые команды: получение процента </a:t>
+            </a:r>
+            <a:r>
+              <a:rPr lang="en-US" sz="2200" dirty="0"/>
+              <a:t>S.M.A.R.T., </a:t>
+            </a:r>
+            <a:r>
+              <a:rPr lang="ru-RU" sz="2200" dirty="0"/>
+              <a:t>времени наработки, объём записанных данных и подобные</a:t>
+            </a:r>
+          </a:p>
+          <a:p>
+            <a:pPr marL="285750" indent="-285750">
+              <a:buFont typeface="Arial" panose="020B0604020202020204" pitchFamily="34" charset="0"/>
+              <a:buChar char="•"/>
+            </a:pPr>
+            <a:r>
+              <a:rPr lang="ru-RU" sz="2200" dirty="0"/>
+              <a:t>Будет порт для </a:t>
+            </a:r>
+            <a:r>
+              <a:rPr lang="en-US" sz="2200" dirty="0"/>
+              <a:t>MacOS, FreeBSD </a:t>
+            </a:r>
+            <a:r>
+              <a:rPr lang="ru-RU" sz="2200" dirty="0"/>
+              <a:t>и других </a:t>
+            </a:r>
+            <a:r>
+              <a:rPr lang="en-US" sz="2200" dirty="0"/>
+              <a:t>UNIX-</a:t>
+            </a:r>
+            <a:r>
+              <a:rPr lang="ru-RU" sz="2200" dirty="0" err="1"/>
+              <a:t>овых</a:t>
+            </a:r>
+            <a:r>
+              <a:rPr lang="ru-RU" sz="2200" dirty="0"/>
+              <a:t> ОС</a:t>
+            </a:r>
+          </a:p>
+          <a:p>
+            <a:pPr marL="285750" indent="-285750">
+              <a:buFont typeface="Arial" panose="020B0604020202020204" pitchFamily="34" charset="0"/>
+              <a:buChar char="•"/>
+            </a:pPr>
+            <a:r>
+              <a:rPr lang="ru-RU" sz="2200" dirty="0"/>
+              <a:t>Планируется добавление поддержки других архитектур</a:t>
+            </a:r>
+          </a:p>
+          <a:p>
+            <a:pPr marL="285750" indent="-285750">
+              <a:buFont typeface="Arial" panose="020B0604020202020204" pitchFamily="34" charset="0"/>
+              <a:buChar char="•"/>
+            </a:pPr>
+            <a:r>
+              <a:rPr lang="ru-RU" sz="2200" dirty="0"/>
+              <a:t>Будут собираться отчеты об ошибках и исправляться баги</a:t>
+            </a:r>
+          </a:p>
+          <a:p>
+            <a:pPr marL="285750" indent="-285750">
+              <a:buFont typeface="Arial" panose="020B0604020202020204" pitchFamily="34" charset="0"/>
+              <a:buChar char="•"/>
+            </a:pPr>
+            <a:r>
+              <a:rPr lang="ru-RU" sz="2200" dirty="0"/>
+              <a:t>Планируется добавление этой программы в репозитории пакетных менеджеров (</a:t>
+            </a:r>
+            <a:r>
+              <a:rPr lang="en-US" sz="2200" dirty="0"/>
+              <a:t>apt, </a:t>
+            </a:r>
+            <a:r>
+              <a:rPr lang="en-US" sz="2200" dirty="0" err="1"/>
+              <a:t>pacman</a:t>
+            </a:r>
+            <a:r>
+              <a:rPr lang="en-US" sz="2200" dirty="0"/>
+              <a:t>, emerge, </a:t>
+            </a:r>
+            <a:r>
+              <a:rPr lang="en-US" sz="2200" dirty="0" err="1"/>
+              <a:t>dnf</a:t>
+            </a:r>
+            <a:r>
+              <a:rPr lang="en-US" sz="2200" dirty="0"/>
+              <a:t> </a:t>
+            </a:r>
+            <a:r>
+              <a:rPr lang="ru-RU" sz="2200" dirty="0"/>
+              <a:t>и других)</a:t>
+            </a:r>
+            <a:endParaRPr lang="en-US" sz="2200" dirty="0"/>
+          </a:p>
+        </p:txBody>
+      </p:sp>
+    </p:spTree>
+    <p:extLst>
+      <p:ext uri="{BB962C8B-B14F-4D97-AF65-F5344CB8AC3E}">
+        <p14:creationId xmlns:p14="http://schemas.microsoft.com/office/powerpoint/2010/main" val="1961248313"/>
+      </p:ext>
+    </p:extLst>
+  </p:cSld>
+  <p:clrMapOvr>
+    <a:masterClrMapping/>
+  </p:clrMapOvr>
+  <mc:AlternateContent xmlns:mc="http://schemas.openxmlformats.org/markup-compatibility/2006" xmlns:p159="http://schemas.microsoft.com/office/powerpoint/2015/09/main">
+    <mc:Choice Requires="p159">
+      <p:transition xmlns:p14="http://schemas.microsoft.com/office/powerpoint/2010/main" spd="slow" p14:dur="2000">
+        <p159:morph option="byObject"/>
+      </p:transition>
+    </mc:Choice>
+    <mc:Fallback xmlns="">
+      <p:transition spd="slow">
+        <p:fade/>
+      </p:transition>
+    </mc:Fallback>
+  </mc:AlternateContent>
+</p:sld>
+</file>
+
+<file path=ppt/slides/slide8.xml><?xml version="1.0" encoding="utf-8"?>
+<p:sld xmlns:a="http://schemas.openxmlformats.org/drawingml/2006/main" xmlns:r="http://schemas.openxmlformats.org/officeDocument/2006/relationships" xmlns:p="http://schemas.openxmlformats.org/presentationml/2006/main">
+  <p:cSld>
+    <p:spTree>
+      <p:nvGrpSpPr>
+        <p:cNvPr id="1" name=""/>
+        <p:cNvGrpSpPr/>
+        <p:nvPr/>
+      </p:nvGrpSpPr>
+      <p:grpSpPr>
+        <a:xfrm>
+          <a:off x="0" y="0"/>
+          <a:ext cx="0" cy="0"/>
+          <a:chOff x="0" y="0"/>
+          <a:chExt cx="0" cy="0"/>
+        </a:xfrm>
+      </p:grpSpPr>
+      <p:sp>
+        <p:nvSpPr>
+          <p:cNvPr id="2" name="Заголовок 1">
+            <a:extLst>
+              <a:ext uri="{FF2B5EF4-FFF2-40B4-BE49-F238E27FC236}">
+                <a16:creationId xmlns:a16="http://schemas.microsoft.com/office/drawing/2014/main" id="{7D943821-AECF-4A55-8E12-49D7F394EDD7}"/>
+              </a:ext>
+            </a:extLst>
+          </p:cNvPr>
+          <p:cNvSpPr>
+            <a:spLocks noGrp="1"/>
+          </p:cNvSpPr>
+          <p:nvPr>
+            <p:ph type="title"/>
+          </p:nvPr>
+        </p:nvSpPr>
+        <p:spPr>
+          <a:xfrm>
+            <a:off x="1359408" y="2766218"/>
+            <a:ext cx="8900160" cy="1325563"/>
+          </a:xfrm>
+        </p:spPr>
+        <p:txBody>
+          <a:bodyPr/>
+          <a:lstStyle/>
+          <a:p>
+            <a:r>
+              <a:rPr lang="ru-RU" dirty="0"/>
+              <a:t>Спасибо за внимание!</a:t>
+            </a:r>
+          </a:p>
+        </p:txBody>
+      </p:sp>
+      <p:pic>
+        <p:nvPicPr>
+          <p:cNvPr id="4" name="Picture 3" descr="A qr code with a few black squares&#10;&#10;AI-generated content may be incorrect.">
+            <a:extLst>
+              <a:ext uri="{FF2B5EF4-FFF2-40B4-BE49-F238E27FC236}">
+                <a16:creationId xmlns:a16="http://schemas.microsoft.com/office/drawing/2014/main" id="{1BCFA2C3-0497-CAA5-FD7A-A8CB123723AA}"/>
+              </a:ext>
+            </a:extLst>
+          </p:cNvPr>
+          <p:cNvPicPr>
+            <a:picLocks noChangeAspect="1"/>
+          </p:cNvPicPr>
+          <p:nvPr/>
+        </p:nvPicPr>
+        <p:blipFill>
+          <a:blip r:embed="rId2">
+            <a:extLst>
+              <a:ext uri="{28A0092B-C50C-407E-A947-70E740481C1C}">
+                <a14:useLocalDpi xmlns:a14="http://schemas.microsoft.com/office/drawing/2010/main" val="0"/>
+              </a:ext>
+            </a:extLst>
+          </a:blip>
+          <a:stretch>
+            <a:fillRect/>
+          </a:stretch>
+        </p:blipFill>
+        <p:spPr>
+          <a:xfrm>
+            <a:off x="7709338" y="1187668"/>
+            <a:ext cx="4482662" cy="4482662"/>
+          </a:xfrm>
+          <a:prstGeom prst="rect">
+            <a:avLst/>
+          </a:prstGeom>
+        </p:spPr>
+      </p:pic>
+      <p:sp>
+        <p:nvSpPr>
+          <p:cNvPr id="5" name="TextBox 4">
+            <a:extLst>
+              <a:ext uri="{FF2B5EF4-FFF2-40B4-BE49-F238E27FC236}">
+                <a16:creationId xmlns:a16="http://schemas.microsoft.com/office/drawing/2014/main" id="{4C3BFE98-C350-885B-94B0-F90C27C73478}"/>
+              </a:ext>
+            </a:extLst>
+          </p:cNvPr>
+          <p:cNvSpPr txBox="1"/>
+          <p:nvPr/>
+        </p:nvSpPr>
+        <p:spPr>
+          <a:xfrm>
+            <a:off x="9268431" y="818336"/>
+            <a:ext cx="1364476" cy="369332"/>
+          </a:xfrm>
+          <a:prstGeom prst="rect">
+            <a:avLst/>
+          </a:prstGeom>
+          <a:noFill/>
+        </p:spPr>
+        <p:txBody>
+          <a:bodyPr wrap="none" rtlCol="0">
+            <a:spAutoFit/>
+          </a:bodyPr>
+          <a:lstStyle/>
+          <a:p>
+            <a:r>
+              <a:rPr lang="ru-RU" dirty="0"/>
+              <a:t>Наш </a:t>
+            </a:r>
+            <a:r>
+              <a:rPr lang="en-US" dirty="0" err="1"/>
+              <a:t>Github</a:t>
+            </a:r>
+            <a:r>
+              <a:rPr lang="en-US" dirty="0"/>
+              <a:t>:</a:t>
+            </a:r>
+          </a:p>
+        </p:txBody>
+      </p:sp>
+      <p:pic>
+        <p:nvPicPr>
+          <p:cNvPr id="2052" name="Picture 4" descr="Gnu logo - Free Icon PNG, SVG">
+            <a:extLst>
+              <a:ext uri="{FF2B5EF4-FFF2-40B4-BE49-F238E27FC236}">
+                <a16:creationId xmlns:a16="http://schemas.microsoft.com/office/drawing/2014/main" id="{393C2445-745E-64E0-6EE1-CAB0D4221B88}"/>
+              </a:ext>
+            </a:extLst>
+          </p:cNvPr>
+          <p:cNvPicPr>
+            <a:picLocks noChangeAspect="1" noChangeArrowheads="1"/>
+          </p:cNvPicPr>
+          <p:nvPr/>
+        </p:nvPicPr>
+        <p:blipFill>
+          <a:blip r:embed="rId3">
+            <a:extLst>
+              <a:ext uri="{28A0092B-C50C-407E-A947-70E740481C1C}">
+                <a14:useLocalDpi xmlns:a14="http://schemas.microsoft.com/office/drawing/2010/main" val="0"/>
+              </a:ext>
+            </a:extLst>
+          </a:blip>
+          <a:srcRect/>
+          <a:stretch>
+            <a:fillRect/>
+          </a:stretch>
+        </p:blipFill>
+        <p:spPr bwMode="auto">
+          <a:xfrm>
+            <a:off x="21967" y="5532435"/>
+            <a:ext cx="1337441" cy="1337441"/>
+          </a:xfrm>
+          <a:prstGeom prst="rect">
+            <a:avLst/>
+          </a:prstGeom>
+          <a:noFill/>
+          <a:extLst>
+            <a:ext uri="{909E8E84-426E-40DD-AFC4-6F175D3DCCD1}">
+              <a14:hiddenFill xmlns:a14="http://schemas.microsoft.com/office/drawing/2010/main">
+                <a:solidFill>
+                  <a:srgbClr val="FFFFFF"/>
+                </a:solidFill>
+              </a14:hiddenFill>
+            </a:ext>
+          </a:extLst>
+        </p:spPr>
+      </p:pic>
+    </p:spTree>
+    <p:extLst>
+      <p:ext uri="{BB962C8B-B14F-4D97-AF65-F5344CB8AC3E}">
+        <p14:creationId xmlns:p14="http://schemas.microsoft.com/office/powerpoint/2010/main" val="419338050"/>
       </p:ext>
     </p:extLst>
   </p:cSld>

</xml_diff>